<commit_message>
docs: streamline pitch presentation to 7 focused slides with enlarged mockups
</commit_message>
<xml_diff>
--- a/Gemce_Pitch_Presentation.pptx
+++ b/Gemce_Pitch_Presentation.pptx
@@ -12,9 +12,6 @@
     <p:sldId id="260" r:id="rId11"/>
     <p:sldId id="261" r:id="rId12"/>
     <p:sldId id="262" r:id="rId13"/>
-    <p:sldId id="263" r:id="rId14"/>
-    <p:sldId id="264" r:id="rId15"/>
-    <p:sldId id="265" r:id="rId16"/>
   </p:sldIdLst>
   <p:sldSz cx="12191695" cy="6858000" type="screen4x3"/>
   <p:notesSz cx="6858000" cy="9144000"/>
@@ -3156,7 +3153,7 @@
         </p:blipFill>
         <p:spPr>
           <a:xfrm>
-            <a:off x="731520" y="1005840"/>
+            <a:off x="731520" y="914400"/>
             <a:ext cx="1097280" cy="1097280"/>
           </a:xfrm>
           <a:prstGeom prst="rect">
@@ -3172,8 +3169,8 @@
         </p:nvSpPr>
         <p:spPr>
           <a:xfrm>
-            <a:off x="731520" y="2286000"/>
-            <a:ext cx="7315200" cy="3474720"/>
+            <a:off x="731520" y="2194560"/>
+            <a:ext cx="7498079" cy="3291840"/>
           </a:xfrm>
           <a:prstGeom prst="rect">
             <a:avLst/>
@@ -3241,7 +3238,7 @@
         <p:spPr>
           <a:xfrm>
             <a:off x="731520" y="4846320"/>
-            <a:ext cx="2011680" cy="384048"/>
+            <a:ext cx="1828800" cy="384048"/>
           </a:xfrm>
           <a:prstGeom prst="roundRect">
             <a:avLst/>
@@ -3282,7 +3279,7 @@
               </a:defRPr>
             </a:pPr>
             <a:r>
-              <a:t>🔒 100% Offline &amp; Private</a:t>
+              <a:t>🔒 100% Offline</a:t>
             </a:r>
           </a:p>
         </p:txBody>
@@ -3295,8 +3292,8 @@
         </p:nvSpPr>
         <p:spPr>
           <a:xfrm>
-            <a:off x="2880360" y="4846320"/>
-            <a:ext cx="2011680" cy="384048"/>
+            <a:off x="2670048" y="4846320"/>
+            <a:ext cx="1828800" cy="384048"/>
           </a:xfrm>
           <a:prstGeom prst="roundRect">
             <a:avLst/>
@@ -3337,7 +3334,7 @@
               </a:defRPr>
             </a:pPr>
             <a:r>
-              <a:t>⚡ Gemma 4 E2B via LiteRT</a:t>
+              <a:t>⚡ Gemma 4 E2B</a:t>
             </a:r>
           </a:p>
         </p:txBody>
@@ -3350,8 +3347,8 @@
         </p:nvSpPr>
         <p:spPr>
           <a:xfrm>
-            <a:off x="5029200" y="4846320"/>
-            <a:ext cx="2011680" cy="384048"/>
+            <a:off x="4608576" y="4846320"/>
+            <a:ext cx="1828800" cy="384048"/>
           </a:xfrm>
           <a:prstGeom prst="roundRect">
             <a:avLst/>
@@ -3392,7 +3389,7 @@
               </a:defRPr>
             </a:pPr>
             <a:r>
-              <a:t>📚 Verbatim Source Citations</a:t>
+              <a:t>📚 Verbatim Citations</a:t>
             </a:r>
           </a:p>
         </p:txBody>
@@ -3405,8 +3402,8 @@
         </p:nvSpPr>
         <p:spPr>
           <a:xfrm>
-            <a:off x="7178040" y="4846320"/>
-            <a:ext cx="2011680" cy="384048"/>
+            <a:off x="6547104" y="4846320"/>
+            <a:ext cx="1828800" cy="384048"/>
           </a:xfrm>
           <a:prstGeom prst="roundRect">
             <a:avLst/>
@@ -3454,7 +3451,7 @@
       </p:sp>
       <p:pic>
         <p:nvPicPr>
-          <p:cNvPr id="9" name="Picture 8" descr="01_start_screen_framed.png"/>
+          <p:cNvPr id="9" name="Picture 8" descr="01_start.png"/>
           <p:cNvPicPr>
             <a:picLocks noChangeAspect="1"/>
           </p:cNvPicPr>
@@ -3468,486 +3465,8 @@
         </p:blipFill>
         <p:spPr>
           <a:xfrm>
-            <a:off x="9326880" y="822960"/>
-            <a:ext cx="2194560" cy="5212080"/>
-          </a:xfrm>
-          <a:prstGeom prst="rect">
-            <a:avLst/>
-          </a:prstGeom>
-        </p:spPr>
-      </p:pic>
-    </p:spTree>
-  </p:cSld>
-  <p:clrMapOvr>
-    <a:masterClrMapping/>
-  </p:clrMapOvr>
-</p:sld>
-</file>
-
-<file path=ppt/slides/slide10.xml><?xml version="1.0" encoding="utf-8"?>
-<p:sld xmlns:a="http://schemas.openxmlformats.org/drawingml/2006/main" xmlns:p="http://schemas.openxmlformats.org/presentationml/2006/main" xmlns:r="http://schemas.openxmlformats.org/officeDocument/2006/relationships">
-  <p:cSld>
-    <p:spTree>
-      <p:nvGrpSpPr>
-        <p:cNvPr id="1" name=""/>
-        <p:cNvGrpSpPr/>
-        <p:nvPr/>
-      </p:nvGrpSpPr>
-      <p:grpSpPr/>
-      <p:sp>
-        <p:nvSpPr>
-          <p:cNvPr id="2" name="Rectangle 1"/>
-          <p:cNvSpPr/>
-          <p:nvPr/>
-        </p:nvSpPr>
-        <p:spPr>
-          <a:xfrm>
-            <a:off x="0" y="0"/>
-            <a:ext cx="12191695" cy="6858000"/>
-          </a:xfrm>
-          <a:prstGeom prst="rect">
-            <a:avLst/>
-          </a:prstGeom>
-          <a:solidFill>
-            <a:srgbClr val="0E1015"/>
-          </a:solidFill>
-          <a:ln>
-            <a:noFill/>
-          </a:ln>
-        </p:spPr>
-        <p:style>
-          <a:lnRef idx="1">
-            <a:schemeClr val="accent1"/>
-          </a:lnRef>
-          <a:fillRef idx="3">
-            <a:schemeClr val="accent1"/>
-          </a:fillRef>
-          <a:effectRef idx="2">
-            <a:schemeClr val="accent1"/>
-          </a:effectRef>
-          <a:fontRef idx="minor">
-            <a:schemeClr val="lt1"/>
-          </a:fontRef>
-        </p:style>
-        <p:txBody>
-          <a:bodyPr rtlCol="0" anchor="ctr"/>
-          <a:lstStyle/>
-          <a:p>
-            <a:pPr algn="ctr"/>
-          </a:p>
-        </p:txBody>
-      </p:sp>
-      <p:sp>
-        <p:nvSpPr>
-          <p:cNvPr id="3" name="Rounded Rectangle 2"/>
-          <p:cNvSpPr/>
-          <p:nvPr/>
-        </p:nvSpPr>
-        <p:spPr>
-          <a:xfrm>
-            <a:off x="731520" y="411480"/>
-            <a:ext cx="3108960" cy="329184"/>
-          </a:xfrm>
-          <a:prstGeom prst="roundRect">
-            <a:avLst/>
-          </a:prstGeom>
-          <a:solidFill>
-            <a:srgbClr val="162D22"/>
-          </a:solidFill>
-          <a:ln w="12700">
-            <a:solidFill>
-              <a:srgbClr val="3DDC84"/>
-            </a:solidFill>
-          </a:ln>
-        </p:spPr>
-        <p:style>
-          <a:lnRef idx="1">
-            <a:schemeClr val="accent1"/>
-          </a:lnRef>
-          <a:fillRef idx="3">
-            <a:schemeClr val="accent1"/>
-          </a:fillRef>
-          <a:effectRef idx="2">
-            <a:schemeClr val="accent1"/>
-          </a:effectRef>
-          <a:fontRef idx="minor">
-            <a:schemeClr val="lt1"/>
-          </a:fontRef>
-        </p:style>
-        <p:txBody>
-          <a:bodyPr rtlCol="0" anchor="ctr" wrap="none" lIns="0" rIns="0" tIns="0" bIns="0"/>
-          <a:lstStyle/>
-          <a:p>
-            <a:pPr algn="ctr">
-              <a:defRPr sz="1000" b="1">
-                <a:solidFill>
-                  <a:srgbClr val="3DDC84"/>
-                </a:solidFill>
-                <a:latin typeface="Arial"/>
-              </a:defRPr>
-            </a:pPr>
-            <a:r>
-              <a:t>09 · ROADMAP &amp; CALL TO ACTION</a:t>
-            </a:r>
-          </a:p>
-        </p:txBody>
-      </p:sp>
-      <p:sp>
-        <p:nvSpPr>
-          <p:cNvPr id="4" name="TextBox 3"/>
-          <p:cNvSpPr txBox="1"/>
-          <p:nvPr/>
-        </p:nvSpPr>
-        <p:spPr>
-          <a:xfrm>
-            <a:off x="731520" y="804672"/>
-            <a:ext cx="10698480" cy="1051560"/>
-          </a:xfrm>
-          <a:prstGeom prst="rect">
-            <a:avLst/>
-          </a:prstGeom>
-          <a:noFill/>
-        </p:spPr>
-        <p:txBody>
-          <a:bodyPr wrap="square" lIns="0" rIns="0" tIns="0" bIns="0">
-            <a:spAutoFit/>
-          </a:bodyPr>
-          <a:lstStyle/>
-          <a:p>
-            <a:pPr>
-              <a:defRPr sz="2500" b="1">
-                <a:solidFill>
-                  <a:srgbClr val="FFFFFF"/>
-                </a:solidFill>
-                <a:latin typeface="Arial"/>
-              </a:defRPr>
-            </a:pPr>
-            <a:r>
-              <a:t>Democratizing AI for Every Student Everywhere</a:t>
-            </a:r>
-          </a:p>
-          <a:p>
-            <a:pPr>
-              <a:spcBef>
-                <a:spcPts val="400"/>
-              </a:spcBef>
-              <a:defRPr sz="1300">
-                <a:solidFill>
-                  <a:srgbClr val="A5AFBE"/>
-                </a:solidFill>
-                <a:latin typeface="Arial"/>
-              </a:defRPr>
-            </a:pPr>
-            <a:r>
-              <a:t>Gemce is open-source, fully verified on physical hardware, and ready for deployment.</a:t>
-            </a:r>
-          </a:p>
-        </p:txBody>
-      </p:sp>
-      <p:sp>
-        <p:nvSpPr>
-          <p:cNvPr id="5" name="Rounded Rectangle 4"/>
-          <p:cNvSpPr/>
-          <p:nvPr/>
-        </p:nvSpPr>
-        <p:spPr>
-          <a:xfrm>
-            <a:off x="731520" y="2011680"/>
-            <a:ext cx="7863840" cy="1234440"/>
-          </a:xfrm>
-          <a:prstGeom prst="roundRect">
-            <a:avLst/>
-          </a:prstGeom>
-          <a:solidFill>
-            <a:srgbClr val="181B24"/>
-          </a:solidFill>
-          <a:ln w="12700">
-            <a:solidFill>
-              <a:srgbClr val="2E3546"/>
-            </a:solidFill>
-          </a:ln>
-        </p:spPr>
-        <p:style>
-          <a:lnRef idx="1">
-            <a:schemeClr val="accent1"/>
-          </a:lnRef>
-          <a:fillRef idx="3">
-            <a:schemeClr val="accent1"/>
-          </a:fillRef>
-          <a:effectRef idx="2">
-            <a:schemeClr val="accent1"/>
-          </a:effectRef>
-          <a:fontRef idx="minor">
-            <a:schemeClr val="lt1"/>
-          </a:fontRef>
-        </p:style>
-        <p:txBody>
-          <a:bodyPr rtlCol="0" anchor="ctr" wrap="square" lIns="228600" rIns="228600" tIns="201168" bIns="201168"/>
-          <a:lstStyle/>
-          <a:p>
-            <a:pPr algn="ctr">
-              <a:spcAft>
-                <a:spcPts val="800"/>
-              </a:spcAft>
-              <a:defRPr sz="1500" b="1">
-                <a:solidFill>
-                  <a:srgbClr val="FFFFFF"/>
-                </a:solidFill>
-                <a:latin typeface="Arial"/>
-              </a:defRPr>
-            </a:pPr>
-            <a:r>
-              <a:t>✅ Shipped MVP Milestones (v0.2.2)</a:t>
-            </a:r>
-          </a:p>
-          <a:p>
-            <a:pPr>
-              <a:spcAft>
-                <a:spcPts val="400"/>
-              </a:spcAft>
-              <a:defRPr sz="1200">
-                <a:solidFill>
-                  <a:srgbClr val="A5AFBE"/>
-                </a:solidFill>
-                <a:latin typeface="Arial"/>
-              </a:defRPr>
-            </a:pPr>
-            <a:r>
-              <a:t>• Full compliance with PLAN.md architecture: OCR/PDF ingest, SM-2 flashcards, MCQs, Reviewers, and Ask Gemce chat.</a:t>
-            </a:r>
-          </a:p>
-          <a:p>
-            <a:pPr>
-              <a:spcAft>
-                <a:spcPts val="400"/>
-              </a:spcAft>
-              <a:defRPr sz="1200">
-                <a:solidFill>
-                  <a:srgbClr val="A5AFBE"/>
-                </a:solidFill>
-                <a:latin typeface="Arial"/>
-              </a:defRPr>
-            </a:pPr>
-            <a:r>
-              <a:t>• Verified on Android 14 (OPPO Reno12 F 5G) with Google Gemma 4 E2B model weights.</a:t>
-            </a:r>
-          </a:p>
-        </p:txBody>
-      </p:sp>
-      <p:sp>
-        <p:nvSpPr>
-          <p:cNvPr id="6" name="Rounded Rectangle 5"/>
-          <p:cNvSpPr/>
-          <p:nvPr/>
-        </p:nvSpPr>
-        <p:spPr>
-          <a:xfrm>
-            <a:off x="731520" y="3383280"/>
-            <a:ext cx="7863840" cy="1234440"/>
-          </a:xfrm>
-          <a:prstGeom prst="roundRect">
-            <a:avLst/>
-          </a:prstGeom>
-          <a:solidFill>
-            <a:srgbClr val="181B24"/>
-          </a:solidFill>
-          <a:ln w="12700">
-            <a:solidFill>
-              <a:srgbClr val="2E3546"/>
-            </a:solidFill>
-          </a:ln>
-        </p:spPr>
-        <p:style>
-          <a:lnRef idx="1">
-            <a:schemeClr val="accent1"/>
-          </a:lnRef>
-          <a:fillRef idx="3">
-            <a:schemeClr val="accent1"/>
-          </a:fillRef>
-          <a:effectRef idx="2">
-            <a:schemeClr val="accent1"/>
-          </a:effectRef>
-          <a:fontRef idx="minor">
-            <a:schemeClr val="lt1"/>
-          </a:fontRef>
-        </p:style>
-        <p:txBody>
-          <a:bodyPr rtlCol="0" anchor="ctr" wrap="square" lIns="228600" rIns="228600" tIns="201168" bIns="201168"/>
-          <a:lstStyle/>
-          <a:p>
-            <a:pPr algn="ctr">
-              <a:spcAft>
-                <a:spcPts val="800"/>
-              </a:spcAft>
-              <a:defRPr sz="1500" b="1">
-                <a:solidFill>
-                  <a:srgbClr val="FFFFFF"/>
-                </a:solidFill>
-                <a:latin typeface="Arial"/>
-              </a:defRPr>
-            </a:pPr>
-            <a:r>
-              <a:t>🚀 Immediate Roadmap (v0.3)</a:t>
-            </a:r>
-          </a:p>
-          <a:p>
-            <a:pPr>
-              <a:spcAft>
-                <a:spcPts val="400"/>
-              </a:spcAft>
-              <a:defRPr sz="1200">
-                <a:solidFill>
-                  <a:srgbClr val="A5AFBE"/>
-                </a:solidFill>
-                <a:latin typeface="Arial"/>
-              </a:defRPr>
-            </a:pPr>
-            <a:r>
-              <a:t>• Anki Deck (.apkg) bidirectional export &amp; import.</a:t>
-            </a:r>
-          </a:p>
-          <a:p>
-            <a:pPr>
-              <a:spcAft>
-                <a:spcPts val="400"/>
-              </a:spcAft>
-              <a:defRPr sz="1200">
-                <a:solidFill>
-                  <a:srgbClr val="A5AFBE"/>
-                </a:solidFill>
-                <a:latin typeface="Arial"/>
-              </a:defRPr>
-            </a:pPr>
-            <a:r>
-              <a:t>• Audio flashcard review mode (hands-free offline playback).</a:t>
-            </a:r>
-          </a:p>
-          <a:p>
-            <a:pPr>
-              <a:spcAft>
-                <a:spcPts val="400"/>
-              </a:spcAft>
-              <a:defRPr sz="1200">
-                <a:solidFill>
-                  <a:srgbClr val="A5AFBE"/>
-                </a:solidFill>
-                <a:latin typeface="Arial"/>
-              </a:defRPr>
-            </a:pPr>
-            <a:r>
-              <a:t>• Camera instant reviewer scanner with camera auto-cropping.</a:t>
-            </a:r>
-          </a:p>
-        </p:txBody>
-      </p:sp>
-      <p:sp>
-        <p:nvSpPr>
-          <p:cNvPr id="7" name="Rounded Rectangle 6"/>
-          <p:cNvSpPr/>
-          <p:nvPr/>
-        </p:nvSpPr>
-        <p:spPr>
-          <a:xfrm>
-            <a:off x="731520" y="4754880"/>
-            <a:ext cx="7863840" cy="1234440"/>
-          </a:xfrm>
-          <a:prstGeom prst="roundRect">
-            <a:avLst/>
-          </a:prstGeom>
-          <a:solidFill>
-            <a:srgbClr val="181B24"/>
-          </a:solidFill>
-          <a:ln w="12700">
-            <a:solidFill>
-              <a:srgbClr val="2E3546"/>
-            </a:solidFill>
-          </a:ln>
-        </p:spPr>
-        <p:style>
-          <a:lnRef idx="1">
-            <a:schemeClr val="accent1"/>
-          </a:lnRef>
-          <a:fillRef idx="3">
-            <a:schemeClr val="accent1"/>
-          </a:fillRef>
-          <a:effectRef idx="2">
-            <a:schemeClr val="accent1"/>
-          </a:effectRef>
-          <a:fontRef idx="minor">
-            <a:schemeClr val="lt1"/>
-          </a:fontRef>
-        </p:style>
-        <p:txBody>
-          <a:bodyPr rtlCol="0" anchor="ctr" wrap="square" lIns="228600" rIns="228600" tIns="201168" bIns="201168"/>
-          <a:lstStyle/>
-          <a:p>
-            <a:pPr algn="ctr">
-              <a:spcAft>
-                <a:spcPts val="800"/>
-              </a:spcAft>
-              <a:defRPr sz="1500" b="1">
-                <a:solidFill>
-                  <a:srgbClr val="FFFFFF"/>
-                </a:solidFill>
-                <a:latin typeface="Arial"/>
-              </a:defRPr>
-            </a:pPr>
-            <a:r>
-              <a:t>📲 Open Source &amp; Distribution</a:t>
-            </a:r>
-          </a:p>
-          <a:p>
-            <a:pPr>
-              <a:spcAft>
-                <a:spcPts val="400"/>
-              </a:spcAft>
-              <a:defRPr sz="1200">
-                <a:solidFill>
-                  <a:srgbClr val="A5AFBE"/>
-                </a:solidFill>
-                <a:latin typeface="Arial"/>
-              </a:defRPr>
-            </a:pPr>
-            <a:r>
-              <a:t>• GitHub Repository: github.com/meloervy/appbuild.gemce</a:t>
-            </a:r>
-          </a:p>
-          <a:p>
-            <a:pPr>
-              <a:spcAft>
-                <a:spcPts val="400"/>
-              </a:spcAft>
-              <a:defRPr sz="1200">
-                <a:solidFill>
-                  <a:srgbClr val="A5AFBE"/>
-                </a:solidFill>
-                <a:latin typeface="Arial"/>
-              </a:defRPr>
-            </a:pPr>
-            <a:r>
-              <a:t>• Installable APK: Packaged via GitHub Actions CI/CD (Gemce-v0.2.2.apk).</a:t>
-            </a:r>
-          </a:p>
-        </p:txBody>
-      </p:sp>
-      <p:pic>
-        <p:nvPicPr>
-          <p:cNvPr id="8" name="Picture 7" descr="06_settings_about_framed.png"/>
-          <p:cNvPicPr>
-            <a:picLocks noChangeAspect="1"/>
-          </p:cNvPicPr>
-          <p:nvPr/>
-        </p:nvPicPr>
-        <p:blipFill>
-          <a:blip r:embed="rId2"/>
-          <a:stretch>
-            <a:fillRect/>
-          </a:stretch>
-        </p:blipFill>
-        <p:spPr>
-          <a:xfrm>
-            <a:off x="9144000" y="1645920"/>
-            <a:ext cx="2148840" cy="4754880"/>
+            <a:off x="8961120" y="731520"/>
+            <a:ext cx="2615184" cy="5394960"/>
           </a:xfrm>
           <a:prstGeom prst="rect">
             <a:avLst/>
@@ -4023,7 +3542,7 @@
         </p:nvSpPr>
         <p:spPr>
           <a:xfrm>
-            <a:off x="731520" y="411480"/>
+            <a:off x="731520" y="384048"/>
             <a:ext cx="3108960" cy="329184"/>
           </a:xfrm>
           <a:prstGeom prst="roundRect">
@@ -4065,7 +3584,7 @@
               </a:defRPr>
             </a:pPr>
             <a:r>
-              <a:t>01 · THE PROBLEM &amp; CONTEXT</a:t>
+              <a:t>01 · PROBLEM &amp; SOLUTION</a:t>
             </a:r>
           </a:p>
         </p:txBody>
@@ -4078,7 +3597,7 @@
         </p:nvSpPr>
         <p:spPr>
           <a:xfrm>
-            <a:off x="731520" y="804672"/>
+            <a:off x="731520" y="777240"/>
             <a:ext cx="10698480" cy="1051560"/>
           </a:xfrm>
           <a:prstGeom prst="rect">
@@ -4101,7 +3620,7 @@
               </a:defRPr>
             </a:pPr>
             <a:r>
-              <a:t>Millions of Students Cannot Rely on Cloud AI</a:t>
+              <a:t>Why Cloud AI Fails — And How Gemce Solves It</a:t>
             </a:r>
           </a:p>
           <a:p>
@@ -4117,7 +3636,7 @@
               </a:defRPr>
             </a:pPr>
             <a:r>
-              <a:t>Cloud-based learning platforms collapse the moment connectivity drops.</a:t>
+              <a:t>Eliminating connectivity barriers, recurring paywalls, and privacy risks.</a:t>
             </a:r>
           </a:p>
         </p:txBody>
@@ -4131,17 +3650,17 @@
         <p:spPr>
           <a:xfrm>
             <a:off x="731520" y="2011680"/>
-            <a:ext cx="3383280" cy="3931920"/>
+            <a:ext cx="5120640" cy="3749039"/>
           </a:xfrm>
           <a:prstGeom prst="roundRect">
             <a:avLst/>
           </a:prstGeom>
           <a:solidFill>
-            <a:srgbClr val="181B24"/>
+            <a:srgbClr val="1C1418"/>
           </a:solidFill>
           <a:ln w="12700">
             <a:solidFill>
-              <a:srgbClr val="2E3546"/>
+              <a:srgbClr val="502D32"/>
             </a:solidFill>
           </a:ln>
         </p:spPr>
@@ -4160,30 +3679,30 @@
           </a:fontRef>
         </p:style>
         <p:txBody>
-          <a:bodyPr rtlCol="0" anchor="ctr" wrap="square" lIns="228600" rIns="228600" tIns="201168" bIns="201168"/>
+          <a:bodyPr rtlCol="0" anchor="ctr" wrap="square" lIns="228600" rIns="228600" tIns="182880" bIns="182880"/>
           <a:lstStyle/>
           <a:p>
             <a:pPr algn="ctr">
               <a:spcAft>
-                <a:spcPts val="800"/>
+                <a:spcPts val="600"/>
               </a:spcAft>
-              <a:defRPr sz="1500" b="1">
-                <a:solidFill>
-                  <a:srgbClr val="FFFFFF"/>
-                </a:solidFill>
-                <a:latin typeface="Arial"/>
-              </a:defRPr>
-            </a:pPr>
-            <a:r>
-              <a:t>📶 Connectivity &amp; Latency Barriers</a:t>
+              <a:defRPr sz="1400" b="1">
+                <a:solidFill>
+                  <a:srgbClr val="F87171"/>
+                </a:solidFill>
+                <a:latin typeface="Arial"/>
+              </a:defRPr>
+            </a:pPr>
+            <a:r>
+              <a:t>❌ The Problem: Cloud AI Limitations</a:t>
             </a:r>
           </a:p>
           <a:p>
             <a:pPr>
               <a:spcAft>
-                <a:spcPts val="400"/>
+                <a:spcPts val="300"/>
               </a:spcAft>
-              <a:defRPr sz="1200">
+              <a:defRPr sz="1150">
                 <a:solidFill>
                   <a:srgbClr val="A5AFBE"/>
                 </a:solidFill>
@@ -4191,15 +3710,15 @@
               </a:defRPr>
             </a:pPr>
             <a:r>
-              <a:t>• High data tariffs and spotty mobile reception across rural schools, transit commutes, and dormitories.</a:t>
+              <a:t>• Fails in Airplane Mode: Cloud AI drops immediately in transit, dorms, or rural areas.</a:t>
             </a:r>
           </a:p>
           <a:p>
             <a:pPr>
               <a:spcAft>
-                <a:spcPts val="400"/>
+                <a:spcPts val="300"/>
               </a:spcAft>
-              <a:defRPr sz="1200">
+              <a:defRPr sz="1150">
                 <a:solidFill>
                   <a:srgbClr val="A5AFBE"/>
                 </a:solidFill>
@@ -4207,15 +3726,15 @@
               </a:defRPr>
             </a:pPr>
             <a:r>
-              <a:t>• Cloud AI tools (ChatGPT, Claude, Gemini Web) completely fail when data runs out or signal is lost.</a:t>
+              <a:t>• Cost Barriers: $20/month subscriptions lock out everyday students.</a:t>
             </a:r>
           </a:p>
           <a:p>
             <a:pPr>
               <a:spcAft>
-                <a:spcPts val="400"/>
+                <a:spcPts val="300"/>
               </a:spcAft>
-              <a:defRPr sz="1200">
+              <a:defRPr sz="1150">
                 <a:solidFill>
                   <a:srgbClr val="A5AFBE"/>
                 </a:solidFill>
@@ -4223,7 +3742,7 @@
               </a:defRPr>
             </a:pPr>
             <a:r>
-              <a:t>• Students are cut off from AI study tools right when they need exam revision the most.</a:t>
+              <a:t>• Privacy Concerns: Uploads private notes and school materials to cloud servers.</a:t>
             </a:r>
           </a:p>
         </p:txBody>
@@ -4236,18 +3755,18 @@
         </p:nvSpPr>
         <p:spPr>
           <a:xfrm>
-            <a:off x="4297680" y="2011680"/>
-            <a:ext cx="3383280" cy="3931920"/>
+            <a:off x="6309360" y="2011680"/>
+            <a:ext cx="5120640" cy="3749039"/>
           </a:xfrm>
           <a:prstGeom prst="roundRect">
             <a:avLst/>
           </a:prstGeom>
           <a:solidFill>
-            <a:srgbClr val="181B24"/>
+            <a:srgbClr val="121E1A"/>
           </a:solidFill>
           <a:ln w="12700">
             <a:solidFill>
-              <a:srgbClr val="2E3546"/>
+              <a:srgbClr val="234B37"/>
             </a:solidFill>
           </a:ln>
         </p:spPr>
@@ -4266,30 +3785,30 @@
           </a:fontRef>
         </p:style>
         <p:txBody>
-          <a:bodyPr rtlCol="0" anchor="ctr" wrap="square" lIns="228600" rIns="228600" tIns="201168" bIns="201168"/>
+          <a:bodyPr rtlCol="0" anchor="ctr" wrap="square" lIns="228600" rIns="228600" tIns="182880" bIns="182880"/>
           <a:lstStyle/>
           <a:p>
             <a:pPr algn="ctr">
               <a:spcAft>
-                <a:spcPts val="800"/>
+                <a:spcPts val="600"/>
               </a:spcAft>
-              <a:defRPr sz="1500" b="1">
-                <a:solidFill>
-                  <a:srgbClr val="FFFFFF"/>
-                </a:solidFill>
-                <a:latin typeface="Arial"/>
-              </a:defRPr>
-            </a:pPr>
-            <a:r>
-              <a:t>💳 Prohibitive Subscription Paywalls</a:t>
+              <a:defRPr sz="1400" b="1">
+                <a:solidFill>
+                  <a:srgbClr val="3DDC84"/>
+                </a:solidFill>
+                <a:latin typeface="Arial"/>
+              </a:defRPr>
+            </a:pPr>
+            <a:r>
+              <a:t>✅ The Solution: Gemce On-Device AI</a:t>
             </a:r>
           </a:p>
           <a:p>
             <a:pPr>
               <a:spcAft>
-                <a:spcPts val="400"/>
+                <a:spcPts val="300"/>
               </a:spcAft>
-              <a:defRPr sz="1200">
+              <a:defRPr sz="1150">
                 <a:solidFill>
                   <a:srgbClr val="A5AFBE"/>
                 </a:solidFill>
@@ -4297,15 +3816,15 @@
               </a:defRPr>
             </a:pPr>
             <a:r>
-              <a:t>• $20/month subscription fees are unattainable for mainstream students in developing economies.</a:t>
+              <a:t>• 100% Local Inference: Runs Google Gemma 4 on-device with zero data connection.</a:t>
             </a:r>
           </a:p>
           <a:p>
             <a:pPr>
               <a:spcAft>
-                <a:spcPts val="400"/>
+                <a:spcPts val="300"/>
               </a:spcAft>
-              <a:defRPr sz="1200">
+              <a:defRPr sz="1150">
                 <a:solidFill>
                   <a:srgbClr val="A5AFBE"/>
                 </a:solidFill>
@@ -4313,15 +3832,15 @@
               </a:defRPr>
             </a:pPr>
             <a:r>
-              <a:t>• Proprietary paywalls gatekeep high-quality tutoring behind credit cards and recurring payments.</a:t>
+              <a:t>• Free &amp; Sovereign: No subscriptions, no telemetry, and complete data privacy.</a:t>
             </a:r>
           </a:p>
           <a:p>
             <a:pPr>
               <a:spcAft>
-                <a:spcPts val="400"/>
+                <a:spcPts val="300"/>
               </a:spcAft>
-              <a:defRPr sz="1200">
+              <a:defRPr sz="1150">
                 <a:solidFill>
                   <a:srgbClr val="A5AFBE"/>
                 </a:solidFill>
@@ -4329,7 +3848,7 @@
               </a:defRPr>
             </a:pPr>
             <a:r>
-              <a:t>• Educational inequality widens as only connected students access AI assistance.</a:t>
+              <a:t>• Verifiable Proof: Every card and question cites exact sentences from student notes.</a:t>
             </a:r>
           </a:p>
         </p:txBody>
@@ -4342,114 +3861,8 @@
         </p:nvSpPr>
         <p:spPr>
           <a:xfrm>
-            <a:off x="7863840" y="2011680"/>
-            <a:ext cx="3383280" cy="3931920"/>
-          </a:xfrm>
-          <a:prstGeom prst="roundRect">
-            <a:avLst/>
-          </a:prstGeom>
-          <a:solidFill>
-            <a:srgbClr val="181B24"/>
-          </a:solidFill>
-          <a:ln w="12700">
-            <a:solidFill>
-              <a:srgbClr val="2E3546"/>
-            </a:solidFill>
-          </a:ln>
-        </p:spPr>
-        <p:style>
-          <a:lnRef idx="1">
-            <a:schemeClr val="accent1"/>
-          </a:lnRef>
-          <a:fillRef idx="3">
-            <a:schemeClr val="accent1"/>
-          </a:fillRef>
-          <a:effectRef idx="2">
-            <a:schemeClr val="accent1"/>
-          </a:effectRef>
-          <a:fontRef idx="minor">
-            <a:schemeClr val="lt1"/>
-          </a:fontRef>
-        </p:style>
-        <p:txBody>
-          <a:bodyPr rtlCol="0" anchor="ctr" wrap="square" lIns="228600" rIns="228600" tIns="201168" bIns="201168"/>
-          <a:lstStyle/>
-          <a:p>
-            <a:pPr algn="ctr">
-              <a:spcAft>
-                <a:spcPts val="800"/>
-              </a:spcAft>
-              <a:defRPr sz="1500" b="1">
-                <a:solidFill>
-                  <a:srgbClr val="FFFFFF"/>
-                </a:solidFill>
-                <a:latin typeface="Arial"/>
-              </a:defRPr>
-            </a:pPr>
-            <a:r>
-              <a:t>🛡️ Data Privacy &amp; Cloud Surveillance</a:t>
-            </a:r>
-          </a:p>
-          <a:p>
-            <a:pPr>
-              <a:spcAft>
-                <a:spcPts val="400"/>
-              </a:spcAft>
-              <a:defRPr sz="1200">
-                <a:solidFill>
-                  <a:srgbClr val="A5AFBE"/>
-                </a:solidFill>
-                <a:latin typeface="Arial"/>
-              </a:defRPr>
-            </a:pPr>
-            <a:r>
-              <a:t>• Uploading student lecture notes, essays, and study materials creates unmonitored cloud data harvesting.</a:t>
-            </a:r>
-          </a:p>
-          <a:p>
-            <a:pPr>
-              <a:spcAft>
-                <a:spcPts val="400"/>
-              </a:spcAft>
-              <a:defRPr sz="1200">
-                <a:solidFill>
-                  <a:srgbClr val="A5AFBE"/>
-                </a:solidFill>
-                <a:latin typeface="Arial"/>
-              </a:defRPr>
-            </a:pPr>
-            <a:r>
-              <a:t>• No data sovereignty: student materials are retained on external corporate servers.</a:t>
-            </a:r>
-          </a:p>
-          <a:p>
-            <a:pPr>
-              <a:spcAft>
-                <a:spcPts val="400"/>
-              </a:spcAft>
-              <a:defRPr sz="1200">
-                <a:solidFill>
-                  <a:srgbClr val="A5AFBE"/>
-                </a:solidFill>
-                <a:latin typeface="Arial"/>
-              </a:defRPr>
-            </a:pPr>
-            <a:r>
-              <a:t>• Institutional compliance issues when handling proprietary textbooks or curriculum syllabi.</a:t>
-            </a:r>
-          </a:p>
-        </p:txBody>
-      </p:sp>
-      <p:sp>
-        <p:nvSpPr>
-          <p:cNvPr id="8" name="Rounded Rectangle 7"/>
-          <p:cNvSpPr/>
-          <p:nvPr/>
-        </p:nvSpPr>
-        <p:spPr>
-          <a:xfrm>
-            <a:off x="731520" y="6080760"/>
-            <a:ext cx="10515600" cy="502920"/>
+            <a:off x="731520" y="5989320"/>
+            <a:ext cx="10698480" cy="502920"/>
           </a:xfrm>
           <a:prstGeom prst="roundRect">
             <a:avLst/>
@@ -4489,7 +3902,7 @@
               </a:defRPr>
             </a:pPr>
             <a:r>
-              <a:t>💡 Fundamental Principle: Quality academic assistance should never be contingent on having a cellular data connection.</a:t>
+              <a:t>💡 Fundamental Principle: Quality academic assistance should never depend on mobile data or costly subscriptions.</a:t>
             </a:r>
           </a:p>
         </p:txBody>
@@ -4563,7 +3976,7 @@
         </p:nvSpPr>
         <p:spPr>
           <a:xfrm>
-            <a:off x="731520" y="411480"/>
+            <a:off x="731520" y="384048"/>
             <a:ext cx="3108960" cy="329184"/>
           </a:xfrm>
           <a:prstGeom prst="roundRect">
@@ -4605,7 +4018,7 @@
               </a:defRPr>
             </a:pPr>
             <a:r>
-              <a:t>02 · THE SOLUTION &amp; ARCHITECTURE</a:t>
+              <a:t>02 · ADAPTIVE STUDY HUB</a:t>
             </a:r>
           </a:p>
         </p:txBody>
@@ -4618,8 +4031,8 @@
         </p:nvSpPr>
         <p:spPr>
           <a:xfrm>
-            <a:off x="731520" y="804672"/>
-            <a:ext cx="10698480" cy="1051560"/>
+            <a:off x="731520" y="777240"/>
+            <a:ext cx="7498079" cy="1051560"/>
           </a:xfrm>
           <a:prstGeom prst="rect">
             <a:avLst/>
@@ -4641,7 +4054,7 @@
               </a:defRPr>
             </a:pPr>
             <a:r>
-              <a:t>Gemce: On-Device AI Study Architecture</a:t>
+              <a:t>Personalized Study Paths Tailored to Your Goals</a:t>
             </a:r>
           </a:p>
           <a:p>
@@ -4657,7 +4070,7 @@
               </a:defRPr>
             </a:pPr>
             <a:r>
-              <a:t>Sovereign on-device intelligence executing Google's Gemma 4 E2B via LiteRT-LM.</a:t>
+              <a:t>Diagnoses student intent and calibrates academic rigor, grade levels, and language.</a:t>
             </a:r>
           </a:p>
         </p:txBody>
@@ -4671,7 +4084,7 @@
         <p:spPr>
           <a:xfrm>
             <a:off x="731520" y="2011680"/>
-            <a:ext cx="7863840" cy="1234440"/>
+            <a:ext cx="6766560" cy="1234440"/>
           </a:xfrm>
           <a:prstGeom prst="roundRect">
             <a:avLst/>
@@ -4700,14 +4113,14 @@
           </a:fontRef>
         </p:style>
         <p:txBody>
-          <a:bodyPr rtlCol="0" anchor="ctr" wrap="square" lIns="228600" rIns="228600" tIns="201168" bIns="201168"/>
+          <a:bodyPr rtlCol="0" anchor="ctr" wrap="square" lIns="228600" rIns="228600" tIns="182880" bIns="182880"/>
           <a:lstStyle/>
           <a:p>
             <a:pPr algn="ctr">
               <a:spcAft>
-                <a:spcPts val="800"/>
+                <a:spcPts val="600"/>
               </a:spcAft>
-              <a:defRPr sz="1500" b="1">
+              <a:defRPr sz="1400" b="1">
                 <a:solidFill>
                   <a:srgbClr val="FFFFFF"/>
                 </a:solidFill>
@@ -4715,15 +4128,15 @@
               </a:defRPr>
             </a:pPr>
             <a:r>
-              <a:t>🔒 100% Local Inference &amp; Offline Guarantee</a:t>
+              <a:t>🎯 Goal-Oriented Learning Modes</a:t>
             </a:r>
           </a:p>
           <a:p>
             <a:pPr>
               <a:spcAft>
-                <a:spcPts val="400"/>
+                <a:spcPts val="300"/>
               </a:spcAft>
-              <a:defRPr sz="1200">
+              <a:defRPr sz="1150">
                 <a:solidFill>
                   <a:srgbClr val="A5AFBE"/>
                 </a:solidFill>
@@ -4731,15 +4144,15 @@
               </a:defRPr>
             </a:pPr>
             <a:r>
-              <a:t>• Over 2.4 GB of quantized model weights stored permanently in on-device storage.</a:t>
+              <a:t>• Diagnoses study intent: Rapid Recall, Exam Practice, Deep Problem Solving, or Reviewers.</a:t>
             </a:r>
           </a:p>
           <a:p>
             <a:pPr>
               <a:spcAft>
-                <a:spcPts val="400"/>
+                <a:spcPts val="300"/>
               </a:spcAft>
-              <a:defRPr sz="1200">
+              <a:defRPr sz="1150">
                 <a:solidFill>
                   <a:srgbClr val="A5AFBE"/>
                 </a:solidFill>
@@ -4747,7 +4160,7 @@
               </a:defRPr>
             </a:pPr>
             <a:r>
-              <a:t>• Zero outbound network requests during study sessions. No tracking, telemetry, or cloud dependencies.</a:t>
+              <a:t>• Automatically prescribes optimal study formats based on topic familiarity.</a:t>
             </a:r>
           </a:p>
         </p:txBody>
@@ -4761,7 +4174,7 @@
         <p:spPr>
           <a:xfrm>
             <a:off x="731520" y="3383280"/>
-            <a:ext cx="7863840" cy="1234440"/>
+            <a:ext cx="6766560" cy="1234440"/>
           </a:xfrm>
           <a:prstGeom prst="roundRect">
             <a:avLst/>
@@ -4790,14 +4203,14 @@
           </a:fontRef>
         </p:style>
         <p:txBody>
-          <a:bodyPr rtlCol="0" anchor="ctr" wrap="square" lIns="228600" rIns="228600" tIns="201168" bIns="201168"/>
+          <a:bodyPr rtlCol="0" anchor="ctr" wrap="square" lIns="228600" rIns="228600" tIns="182880" bIns="182880"/>
           <a:lstStyle/>
           <a:p>
             <a:pPr algn="ctr">
               <a:spcAft>
-                <a:spcPts val="800"/>
+                <a:spcPts val="600"/>
               </a:spcAft>
-              <a:defRPr sz="1500" b="1">
+              <a:defRPr sz="1400" b="1">
                 <a:solidFill>
                   <a:srgbClr val="FFFFFF"/>
                 </a:solidFill>
@@ -4805,15 +4218,15 @@
               </a:defRPr>
             </a:pPr>
             <a:r>
-              <a:t>⚡ Google LiteRT-LM GPU Accelerated Engine</a:t>
+              <a:t>🎓 Academic Level &amp; Major Calibration</a:t>
             </a:r>
           </a:p>
           <a:p>
             <a:pPr>
               <a:spcAft>
-                <a:spcPts val="400"/>
+                <a:spcPts val="300"/>
               </a:spcAft>
-              <a:defRPr sz="1200">
+              <a:defRPr sz="1150">
                 <a:solidFill>
                   <a:srgbClr val="A5AFBE"/>
                 </a:solidFill>
@@ -4821,15 +4234,15 @@
               </a:defRPr>
             </a:pPr>
             <a:r>
-              <a:t>• Direct execution on Android OpenCL GPU backend (Adreno / Mali).</a:t>
+              <a:t>• Calibrates technical depth from Junior/Senior High tracks to specialized College majors.</a:t>
             </a:r>
           </a:p>
           <a:p>
             <a:pPr>
               <a:spcAft>
-                <a:spcPts val="400"/>
+                <a:spcPts val="300"/>
               </a:spcAft>
-              <a:defRPr sz="1200">
+              <a:defRPr sz="1150">
                 <a:solidFill>
                   <a:srgbClr val="A5AFBE"/>
                 </a:solidFill>
@@ -4837,7 +4250,7 @@
               </a:defRPr>
             </a:pPr>
             <a:r>
-              <a:t>• Sub-second Time-To-First-Token and smooth streaming token generation on modern Android devices.</a:t>
+              <a:t>• Tailors difficulty for Accountancy, Nursing, Engineering, CS, and Humanities.</a:t>
             </a:r>
           </a:p>
         </p:txBody>
@@ -4851,7 +4264,7 @@
         <p:spPr>
           <a:xfrm>
             <a:off x="731520" y="4754880"/>
-            <a:ext cx="7863840" cy="1234440"/>
+            <a:ext cx="6766560" cy="1234440"/>
           </a:xfrm>
           <a:prstGeom prst="roundRect">
             <a:avLst/>
@@ -4880,14 +4293,14 @@
           </a:fontRef>
         </p:style>
         <p:txBody>
-          <a:bodyPr rtlCol="0" anchor="ctr" wrap="square" lIns="228600" rIns="228600" tIns="201168" bIns="201168"/>
+          <a:bodyPr rtlCol="0" anchor="ctr" wrap="square" lIns="228600" rIns="228600" tIns="182880" bIns="182880"/>
           <a:lstStyle/>
           <a:p>
             <a:pPr algn="ctr">
               <a:spcAft>
-                <a:spcPts val="800"/>
+                <a:spcPts val="600"/>
               </a:spcAft>
-              <a:defRPr sz="1500" b="1">
+              <a:defRPr sz="1400" b="1">
                 <a:solidFill>
                   <a:srgbClr val="FFFFFF"/>
                 </a:solidFill>
@@ -4895,15 +4308,15 @@
               </a:defRPr>
             </a:pPr>
             <a:r>
-              <a:t>📦 Persistent Weights &amp; Zero-AI Fallback</a:t>
+              <a:t>🌐 Multilingual Academic Mentoring</a:t>
             </a:r>
           </a:p>
           <a:p>
             <a:pPr>
               <a:spcAft>
-                <a:spcPts val="400"/>
+                <a:spcPts val="300"/>
               </a:spcAft>
-              <a:defRPr sz="1200">
+              <a:defRPr sz="1150">
                 <a:solidFill>
                   <a:srgbClr val="A5AFBE"/>
                 </a:solidFill>
@@ -4911,15 +4324,15 @@
               </a:defRPr>
             </a:pPr>
             <a:r>
-              <a:t>• Model file survives app updates, cache clears, and uninstalls.</a:t>
+              <a:t>• Speaks English, Filipino (Tagalog), Taglish, and Cebuano (Bisaya).</a:t>
             </a:r>
           </a:p>
           <a:p>
             <a:pPr>
               <a:spcAft>
-                <a:spcPts val="400"/>
+                <a:spcPts val="300"/>
               </a:spcAft>
-              <a:defRPr sz="1200">
+              <a:defRPr sz="1150">
                 <a:solidFill>
                   <a:srgbClr val="A5AFBE"/>
                 </a:solidFill>
@@ -4927,14 +4340,14 @@
               </a:defRPr>
             </a:pPr>
             <a:r>
-              <a:t>• Manual flashcards, deck browsing, and SM-2 scheduling remain 100% functional even with zero AI.</a:t>
+              <a:t>• Explains tough concepts in the student's natural, conversational tongue.</a:t>
             </a:r>
           </a:p>
         </p:txBody>
       </p:sp>
       <p:pic>
         <p:nvPicPr>
-          <p:cNvPr id="8" name="Picture 7" descr="05_settings_engine_framed.png"/>
+          <p:cNvPr id="8" name="Picture 7" descr="02_study_hub.png"/>
           <p:cNvPicPr>
             <a:picLocks noChangeAspect="1"/>
           </p:cNvPicPr>
@@ -4948,8 +4361,8 @@
         </p:blipFill>
         <p:spPr>
           <a:xfrm>
-            <a:off x="9144000" y="1645920"/>
-            <a:ext cx="2148840" cy="4754880"/>
+            <a:off x="8412480" y="1097280"/>
+            <a:ext cx="2606040" cy="5349240"/>
           </a:xfrm>
           <a:prstGeom prst="rect">
             <a:avLst/>
@@ -5025,7 +4438,7 @@
         </p:nvSpPr>
         <p:spPr>
           <a:xfrm>
-            <a:off x="731520" y="411480"/>
+            <a:off x="731520" y="384048"/>
             <a:ext cx="3108960" cy="329184"/>
           </a:xfrm>
           <a:prstGeom prst="roundRect">
@@ -5067,7 +4480,7 @@
               </a:defRPr>
             </a:pPr>
             <a:r>
-              <a:t>03 · CURRICULUM CALIBRATION</a:t>
+              <a:t>03 · ACTIVE RECALL</a:t>
             </a:r>
           </a:p>
         </p:txBody>
@@ -5080,8 +4493,8 @@
         </p:nvSpPr>
         <p:spPr>
           <a:xfrm>
-            <a:off x="731520" y="804672"/>
-            <a:ext cx="10698480" cy="1051560"/>
+            <a:off x="731520" y="777240"/>
+            <a:ext cx="5486400" cy="1051560"/>
           </a:xfrm>
           <a:prstGeom prst="rect">
             <a:avLst/>
@@ -5103,7 +4516,7 @@
               </a:defRPr>
             </a:pPr>
             <a:r>
-              <a:t>Tailored Rigor Across Disciplines &amp; Languages</a:t>
+              <a:t>Evidence-Grounded Flashcards with SuperMemo SM-2</a:t>
             </a:r>
           </a:p>
           <a:p>
@@ -5119,7 +4532,7 @@
               </a:defRPr>
             </a:pPr>
             <a:r>
-              <a:t>Calibrates explanation depth, curriculum context, and vocabulary to the student.</a:t>
+              <a:t>Spaced repetition paired with zero-hallucination source grounding.</a:t>
             </a:r>
           </a:p>
         </p:txBody>
@@ -5133,7 +4546,7 @@
         <p:spPr>
           <a:xfrm>
             <a:off x="731520" y="2011680"/>
-            <a:ext cx="7863840" cy="1234440"/>
+            <a:ext cx="5120640" cy="1234440"/>
           </a:xfrm>
           <a:prstGeom prst="roundRect">
             <a:avLst/>
@@ -5162,14 +4575,14 @@
           </a:fontRef>
         </p:style>
         <p:txBody>
-          <a:bodyPr rtlCol="0" anchor="ctr" wrap="square" lIns="228600" rIns="228600" tIns="201168" bIns="201168"/>
+          <a:bodyPr rtlCol="0" anchor="ctr" wrap="square" lIns="228600" rIns="228600" tIns="182880" bIns="182880"/>
           <a:lstStyle/>
           <a:p>
             <a:pPr algn="ctr">
               <a:spcAft>
-                <a:spcPts val="800"/>
+                <a:spcPts val="600"/>
               </a:spcAft>
-              <a:defRPr sz="1500" b="1">
+              <a:defRPr sz="1400" b="1">
                 <a:solidFill>
                   <a:srgbClr val="FFFFFF"/>
                 </a:solidFill>
@@ -5177,15 +4590,15 @@
               </a:defRPr>
             </a:pPr>
             <a:r>
-              <a:t>🎓 Dynamic Academic Level Calibration</a:t>
+              <a:t>🧠 SuperMemo SM-2 Spaced Repetition</a:t>
             </a:r>
           </a:p>
           <a:p>
             <a:pPr>
               <a:spcAft>
-                <a:spcPts val="400"/>
+                <a:spcPts val="300"/>
               </a:spcAft>
-              <a:defRPr sz="1200">
+              <a:defRPr sz="1150">
                 <a:solidFill>
                   <a:srgbClr val="A5AFBE"/>
                 </a:solidFill>
@@ -5193,15 +4606,15 @@
               </a:defRPr>
             </a:pPr>
             <a:r>
-              <a:t>• Calibrates from Junior High, Senior High tracks (GAS, HUMSS, ABM, STEM, TVL, Arts) to College majors.</a:t>
+              <a:t>• Dynamically schedules review intervals (Again, Hard, Good, Easy).</a:t>
             </a:r>
           </a:p>
           <a:p>
             <a:pPr>
               <a:spcAft>
-                <a:spcPts val="400"/>
+                <a:spcPts val="300"/>
               </a:spcAft>
-              <a:defRPr sz="1200">
+              <a:defRPr sz="1150">
                 <a:solidFill>
                   <a:srgbClr val="A5AFBE"/>
                 </a:solidFill>
@@ -5209,7 +4622,7 @@
               </a:defRPr>
             </a:pPr>
             <a:r>
-              <a:t>• Aligns technical vocabulary and pedagogical depth to university programs like Accountancy, Nursing, Education, and Engineering.</a:t>
+              <a:t>• Optimizes long-term memory retention before examinations.</a:t>
             </a:r>
           </a:p>
         </p:txBody>
@@ -5223,7 +4636,7 @@
         <p:spPr>
           <a:xfrm>
             <a:off x="731520" y="3383280"/>
-            <a:ext cx="7863840" cy="1234440"/>
+            <a:ext cx="5120640" cy="1234440"/>
           </a:xfrm>
           <a:prstGeom prst="roundRect">
             <a:avLst/>
@@ -5252,14 +4665,14 @@
           </a:fontRef>
         </p:style>
         <p:txBody>
-          <a:bodyPr rtlCol="0" anchor="ctr" wrap="square" lIns="228600" rIns="228600" tIns="201168" bIns="201168"/>
+          <a:bodyPr rtlCol="0" anchor="ctr" wrap="square" lIns="228600" rIns="228600" tIns="182880" bIns="182880"/>
           <a:lstStyle/>
           <a:p>
             <a:pPr algn="ctr">
               <a:spcAft>
-                <a:spcPts val="800"/>
+                <a:spcPts val="600"/>
               </a:spcAft>
-              <a:defRPr sz="1500" b="1">
+              <a:defRPr sz="1400" b="1">
                 <a:solidFill>
                   <a:srgbClr val="FFFFFF"/>
                 </a:solidFill>
@@ -5267,15 +4680,15 @@
               </a:defRPr>
             </a:pPr>
             <a:r>
-              <a:t>🌐 Multilingual Academic Tutoring</a:t>
+              <a:t>🚫 Strict Anti-Hallucination Prompts</a:t>
             </a:r>
           </a:p>
           <a:p>
             <a:pPr>
               <a:spcAft>
-                <a:spcPts val="400"/>
+                <a:spcPts val="300"/>
               </a:spcAft>
-              <a:defRPr sz="1200">
+              <a:defRPr sz="1150">
                 <a:solidFill>
                   <a:srgbClr val="A5AFBE"/>
                 </a:solidFill>
@@ -5283,15 +4696,15 @@
               </a:defRPr>
             </a:pPr>
             <a:r>
-              <a:t>• Speaks English, Filipino (Tagalog), Taglish, and Binisaya (Cebuano).</a:t>
+              <a:t>• Forbids generic meta-questions like 'What did the user intend to study?'.</a:t>
             </a:r>
           </a:p>
           <a:p>
             <a:pPr>
               <a:spcAft>
-                <a:spcPts val="400"/>
+                <a:spcPts val="300"/>
               </a:spcAft>
-              <a:defRPr sz="1200">
+              <a:defRPr sz="1150">
                 <a:solidFill>
                   <a:srgbClr val="A5AFBE"/>
                 </a:solidFill>
@@ -5299,7 +4712,7 @@
               </a:defRPr>
             </a:pPr>
             <a:r>
-              <a:t>• Students understand tough conceptual mechanisms in their natural, conversational tongue.</a:t>
+              <a:t>• Tests concrete academic mechanisms: Mitochondria, ATP synthesis, rock types.</a:t>
             </a:r>
           </a:p>
         </p:txBody>
@@ -5313,7 +4726,7 @@
         <p:spPr>
           <a:xfrm>
             <a:off x="731520" y="4754880"/>
-            <a:ext cx="7863840" cy="1234440"/>
+            <a:ext cx="5120640" cy="1234440"/>
           </a:xfrm>
           <a:prstGeom prst="roundRect">
             <a:avLst/>
@@ -5342,14 +4755,14 @@
           </a:fontRef>
         </p:style>
         <p:txBody>
-          <a:bodyPr rtlCol="0" anchor="ctr" wrap="square" lIns="228600" rIns="228600" tIns="201168" bIns="201168"/>
+          <a:bodyPr rtlCol="0" anchor="ctr" wrap="square" lIns="228600" rIns="228600" tIns="182880" bIns="182880"/>
           <a:lstStyle/>
           <a:p>
             <a:pPr algn="ctr">
               <a:spcAft>
-                <a:spcPts val="800"/>
+                <a:spcPts val="600"/>
               </a:spcAft>
-              <a:defRPr sz="1500" b="1">
+              <a:defRPr sz="1400" b="1">
                 <a:solidFill>
                   <a:srgbClr val="FFFFFF"/>
                 </a:solidFill>
@@ -5357,15 +4770,15 @@
               </a:defRPr>
             </a:pPr>
             <a:r>
-              <a:t>📖 Packaged Reading Typography</a:t>
+              <a:t>📖 Verbatim Source Provenance</a:t>
             </a:r>
           </a:p>
           <a:p>
             <a:pPr>
               <a:spcAft>
-                <a:spcPts val="400"/>
+                <a:spcPts val="300"/>
               </a:spcAft>
-              <a:defRPr sz="1200">
+              <a:defRPr sz="1150">
                 <a:solidFill>
                   <a:srgbClr val="A5AFBE"/>
                 </a:solidFill>
@@ -5373,15 +4786,15 @@
               </a:defRPr>
             </a:pPr>
             <a:r>
-              <a:t>• Bundles packaged TrueType fonts: Calibri (modern), Serif (editorial), and Monospace (STEM).</a:t>
+              <a:t>• Highlights verbatim source sentences on the card back.</a:t>
             </a:r>
           </a:p>
           <a:p>
             <a:pPr>
               <a:spcAft>
-                <a:spcPts val="400"/>
+                <a:spcPts val="300"/>
               </a:spcAft>
-              <a:defRPr sz="1200">
+              <a:defRPr sz="1150">
                 <a:solidFill>
                   <a:srgbClr val="A5AFBE"/>
                 </a:solidFill>
@@ -5389,14 +4802,14 @@
               </a:defRPr>
             </a:pPr>
             <a:r>
-              <a:t>• System-wide font selection optimizes legibility for dense textbook reading sessions.</a:t>
+              <a:t>• Guarantees 100% factual accuracy with zero AI hallucinations.</a:t>
             </a:r>
           </a:p>
         </p:txBody>
       </p:sp>
       <p:pic>
         <p:nvPicPr>
-          <p:cNvPr id="8" name="Picture 7" descr="04_profile_dialog_framed.png"/>
+          <p:cNvPr id="8" name="Picture 7" descr="04_card_front.png"/>
           <p:cNvPicPr>
             <a:picLocks noChangeAspect="1"/>
           </p:cNvPicPr>
@@ -5410,8 +4823,32 @@
         </p:blipFill>
         <p:spPr>
           <a:xfrm>
-            <a:off x="9144000" y="1645920"/>
-            <a:ext cx="2148840" cy="4754880"/>
+            <a:off x="6400800" y="1097280"/>
+            <a:ext cx="2560320" cy="5303520"/>
+          </a:xfrm>
+          <a:prstGeom prst="rect">
+            <a:avLst/>
+          </a:prstGeom>
+        </p:spPr>
+      </p:pic>
+      <p:pic>
+        <p:nvPicPr>
+          <p:cNvPr id="9" name="Picture 8" descr="05_card_back.png"/>
+          <p:cNvPicPr>
+            <a:picLocks noChangeAspect="1"/>
+          </p:cNvPicPr>
+          <p:nvPr/>
+        </p:nvPicPr>
+        <p:blipFill>
+          <a:blip r:embed="rId3"/>
+          <a:stretch>
+            <a:fillRect/>
+          </a:stretch>
+        </p:blipFill>
+        <p:spPr>
+          <a:xfrm>
+            <a:off x="9235440" y="1097280"/>
+            <a:ext cx="2560320" cy="5303520"/>
           </a:xfrm>
           <a:prstGeom prst="rect">
             <a:avLst/>
@@ -5487,7 +4924,7 @@
         </p:nvSpPr>
         <p:spPr>
           <a:xfrm>
-            <a:off x="731520" y="411480"/>
+            <a:off x="731520" y="384048"/>
             <a:ext cx="3108960" cy="329184"/>
           </a:xfrm>
           <a:prstGeom prst="roundRect">
@@ -5529,7 +4966,7 @@
               </a:defRPr>
             </a:pPr>
             <a:r>
-              <a:t>04 · STUDY METHODOLOGY</a:t>
+              <a:t>04 · EXAM PREPARATION</a:t>
             </a:r>
           </a:p>
         </p:txBody>
@@ -5542,8 +4979,8 @@
         </p:nvSpPr>
         <p:spPr>
           <a:xfrm>
-            <a:off x="731520" y="804672"/>
-            <a:ext cx="10698480" cy="1051560"/>
+            <a:off x="731520" y="777240"/>
+            <a:ext cx="5486400" cy="1051560"/>
           </a:xfrm>
           <a:prstGeom prst="rect">
             <a:avLst/>
@@ -5565,7 +5002,7 @@
               </a:defRPr>
             </a:pPr>
             <a:r>
-              <a:t>Adaptive Study Hub &amp; Intelligent Diagnosis</a:t>
+              <a:t>Interactive Practice Quizzes &amp; Instant Evaluation</a:t>
             </a:r>
           </a:p>
           <a:p>
@@ -5581,7 +5018,7 @@
               </a:defRPr>
             </a:pPr>
             <a:r>
-              <a:t>Transforms raw syllabus topics and lecture notes into goal-oriented learning workflows.</a:t>
+              <a:t>4-option MCQs with instant scoring and explanatory rationales.</a:t>
             </a:r>
           </a:p>
         </p:txBody>
@@ -5595,7 +5032,7 @@
         <p:spPr>
           <a:xfrm>
             <a:off x="731520" y="2011680"/>
-            <a:ext cx="3749039" cy="1737360"/>
+            <a:ext cx="5120640" cy="1234440"/>
           </a:xfrm>
           <a:prstGeom prst="roundRect">
             <a:avLst/>
@@ -5624,14 +5061,14 @@
           </a:fontRef>
         </p:style>
         <p:txBody>
-          <a:bodyPr rtlCol="0" anchor="ctr" wrap="square" lIns="228600" rIns="228600" tIns="201168" bIns="201168"/>
+          <a:bodyPr rtlCol="0" anchor="ctr" wrap="square" lIns="228600" rIns="228600" tIns="182880" bIns="182880"/>
           <a:lstStyle/>
           <a:p>
             <a:pPr algn="ctr">
               <a:spcAft>
-                <a:spcPts val="800"/>
+                <a:spcPts val="600"/>
               </a:spcAft>
-              <a:defRPr sz="1500" b="1">
+              <a:defRPr sz="1400" b="1">
                 <a:solidFill>
                   <a:srgbClr val="FFFFFF"/>
                 </a:solidFill>
@@ -5639,15 +5076,15 @@
               </a:defRPr>
             </a:pPr>
             <a:r>
-              <a:t>⚡ 1. Rapid Recall &amp; Formulas</a:t>
+              <a:t>🎯 4-Option Multiple Choice Assessments</a:t>
             </a:r>
           </a:p>
           <a:p>
             <a:pPr>
               <a:spcAft>
-                <a:spcPts val="400"/>
+                <a:spcPts val="300"/>
               </a:spcAft>
-              <a:defRPr sz="1200">
+              <a:defRPr sz="1150">
                 <a:solidFill>
                   <a:srgbClr val="A5AFBE"/>
                 </a:solidFill>
@@ -5655,15 +5092,15 @@
               </a:defRPr>
             </a:pPr>
             <a:r>
-              <a:t>• Diagnoses active retention goals.</a:t>
+              <a:t>• Rigorous MCQs testing conceptual mastery and analytical discrimination.</a:t>
             </a:r>
           </a:p>
           <a:p>
             <a:pPr>
               <a:spcAft>
-                <a:spcPts val="400"/>
+                <a:spcPts val="300"/>
               </a:spcAft>
-              <a:defRPr sz="1200">
+              <a:defRPr sz="1150">
                 <a:solidFill>
                   <a:srgbClr val="A5AFBE"/>
                 </a:solidFill>
@@ -5671,7 +5108,7 @@
               </a:defRPr>
             </a:pPr>
             <a:r>
-              <a:t>• Prescribes Spaced Repetition Flashcards powered by SuperMemo SM-2.</a:t>
+              <a:t>• Challenges students to apply principles rather than passively re-read.</a:t>
             </a:r>
           </a:p>
         </p:txBody>
@@ -5684,8 +5121,8 @@
         </p:nvSpPr>
         <p:spPr>
           <a:xfrm>
-            <a:off x="4663440" y="2011680"/>
-            <a:ext cx="3749039" cy="1737360"/>
+            <a:off x="731520" y="3383280"/>
+            <a:ext cx="5120640" cy="1234440"/>
           </a:xfrm>
           <a:prstGeom prst="roundRect">
             <a:avLst/>
@@ -5714,14 +5151,14 @@
           </a:fontRef>
         </p:style>
         <p:txBody>
-          <a:bodyPr rtlCol="0" anchor="ctr" wrap="square" lIns="228600" rIns="228600" tIns="201168" bIns="201168"/>
+          <a:bodyPr rtlCol="0" anchor="ctr" wrap="square" lIns="228600" rIns="228600" tIns="182880" bIns="182880"/>
           <a:lstStyle/>
           <a:p>
             <a:pPr algn="ctr">
               <a:spcAft>
-                <a:spcPts val="800"/>
+                <a:spcPts val="600"/>
               </a:spcAft>
-              <a:defRPr sz="1500" b="1">
+              <a:defRPr sz="1400" b="1">
                 <a:solidFill>
                   <a:srgbClr val="FFFFFF"/>
                 </a:solidFill>
@@ -5729,15 +5166,15 @@
               </a:defRPr>
             </a:pPr>
             <a:r>
-              <a:t>🎯 2. Exam Practice &amp; Quizzes</a:t>
+              <a:t>⚡ Instant Grading &amp; Rationale Explanations</a:t>
             </a:r>
           </a:p>
           <a:p>
             <a:pPr>
               <a:spcAft>
-                <a:spcPts val="400"/>
+                <a:spcPts val="300"/>
               </a:spcAft>
-              <a:defRPr sz="1200">
+              <a:defRPr sz="1150">
                 <a:solidFill>
                   <a:srgbClr val="A5AFBE"/>
                 </a:solidFill>
@@ -5745,15 +5182,15 @@
               </a:defRPr>
             </a:pPr>
             <a:r>
-              <a:t>• Diagnoses test preparation goals.</a:t>
+              <a:t>• Instantly highlights incorrect selections in red and correct choices in teal.</a:t>
             </a:r>
           </a:p>
           <a:p>
             <a:pPr>
               <a:spcAft>
-                <a:spcPts val="400"/>
+                <a:spcPts val="300"/>
               </a:spcAft>
-              <a:defRPr sz="1200">
+              <a:defRPr sz="1150">
                 <a:solidFill>
                   <a:srgbClr val="A5AFBE"/>
                 </a:solidFill>
@@ -5761,7 +5198,7 @@
               </a:defRPr>
             </a:pPr>
             <a:r>
-              <a:t>• Prescribes instant Multiple-Choice Questions with rationale feedback.</a:t>
+              <a:t>• Explanatory rationale box details the exact conceptual reason.</a:t>
             </a:r>
           </a:p>
         </p:txBody>
@@ -5774,8 +5211,8 @@
         </p:nvSpPr>
         <p:spPr>
           <a:xfrm>
-            <a:off x="731520" y="3931920"/>
-            <a:ext cx="3749039" cy="1737360"/>
+            <a:off x="731520" y="4754880"/>
+            <a:ext cx="5120640" cy="1234440"/>
           </a:xfrm>
           <a:prstGeom prst="roundRect">
             <a:avLst/>
@@ -5804,14 +5241,14 @@
           </a:fontRef>
         </p:style>
         <p:txBody>
-          <a:bodyPr rtlCol="0" anchor="ctr" wrap="square" lIns="228600" rIns="228600" tIns="201168" bIns="201168"/>
+          <a:bodyPr rtlCol="0" anchor="ctr" wrap="square" lIns="228600" rIns="228600" tIns="182880" bIns="182880"/>
           <a:lstStyle/>
           <a:p>
             <a:pPr algn="ctr">
               <a:spcAft>
-                <a:spcPts val="800"/>
+                <a:spcPts val="600"/>
               </a:spcAft>
-              <a:defRPr sz="1500" b="1">
+              <a:defRPr sz="1400" b="1">
                 <a:solidFill>
                   <a:srgbClr val="FFFFFF"/>
                 </a:solidFill>
@@ -5819,15 +5256,15 @@
               </a:defRPr>
             </a:pPr>
             <a:r>
-              <a:t>🧠 3. Deep Problem Solving</a:t>
+              <a:t>📚 100% Material Grounding</a:t>
             </a:r>
           </a:p>
           <a:p>
             <a:pPr>
               <a:spcAft>
-                <a:spcPts val="400"/>
+                <a:spcPts val="300"/>
               </a:spcAft>
-              <a:defRPr sz="1200">
+              <a:defRPr sz="1150">
                 <a:solidFill>
                   <a:srgbClr val="A5AFBE"/>
                 </a:solidFill>
@@ -5835,15 +5272,15 @@
               </a:defRPr>
             </a:pPr>
             <a:r>
-              <a:t>• Diagnoses deep conceptual synthesis.</a:t>
+              <a:t>• Every question, distractor, and rationale derives directly from student notes.</a:t>
             </a:r>
           </a:p>
           <a:p>
             <a:pPr>
               <a:spcAft>
-                <a:spcPts val="400"/>
+                <a:spcPts val="300"/>
               </a:spcAft>
-              <a:defRPr sz="1200">
+              <a:defRPr sz="1150">
                 <a:solidFill>
                   <a:srgbClr val="A5AFBE"/>
                 </a:solidFill>
@@ -5851,104 +5288,14 @@
               </a:defRPr>
             </a:pPr>
             <a:r>
-              <a:t>• Prescribes short-answer essay questions evaluated against rubrics.</a:t>
-            </a:r>
-          </a:p>
-        </p:txBody>
-      </p:sp>
-      <p:sp>
-        <p:nvSpPr>
-          <p:cNvPr id="8" name="Rounded Rectangle 7"/>
-          <p:cNvSpPr/>
-          <p:nvPr/>
-        </p:nvSpPr>
-        <p:spPr>
-          <a:xfrm>
-            <a:off x="4663440" y="3931920"/>
-            <a:ext cx="3749039" cy="1737360"/>
-          </a:xfrm>
-          <a:prstGeom prst="roundRect">
-            <a:avLst/>
-          </a:prstGeom>
-          <a:solidFill>
-            <a:srgbClr val="181B24"/>
-          </a:solidFill>
-          <a:ln w="12700">
-            <a:solidFill>
-              <a:srgbClr val="2E3546"/>
-            </a:solidFill>
-          </a:ln>
-        </p:spPr>
-        <p:style>
-          <a:lnRef idx="1">
-            <a:schemeClr val="accent1"/>
-          </a:lnRef>
-          <a:fillRef idx="3">
-            <a:schemeClr val="accent1"/>
-          </a:fillRef>
-          <a:effectRef idx="2">
-            <a:schemeClr val="accent1"/>
-          </a:effectRef>
-          <a:fontRef idx="minor">
-            <a:schemeClr val="lt1"/>
-          </a:fontRef>
-        </p:style>
-        <p:txBody>
-          <a:bodyPr rtlCol="0" anchor="ctr" wrap="square" lIns="228600" rIns="228600" tIns="201168" bIns="201168"/>
-          <a:lstStyle/>
-          <a:p>
-            <a:pPr algn="ctr">
-              <a:spcAft>
-                <a:spcPts val="800"/>
-              </a:spcAft>
-              <a:defRPr sz="1500" b="1">
-                <a:solidFill>
-                  <a:srgbClr val="FFFFFF"/>
-                </a:solidFill>
-                <a:latin typeface="Arial"/>
-              </a:defRPr>
-            </a:pPr>
-            <a:r>
-              <a:t>📖 4. Comprehensive Reviewer</a:t>
-            </a:r>
-          </a:p>
-          <a:p>
-            <a:pPr>
-              <a:spcAft>
-                <a:spcPts val="400"/>
-              </a:spcAft>
-              <a:defRPr sz="1200">
-                <a:solidFill>
-                  <a:srgbClr val="A5AFBE"/>
-                </a:solidFill>
-                <a:latin typeface="Arial"/>
-              </a:defRPr>
-            </a:pPr>
-            <a:r>
-              <a:t>• Diagnoses structured pre-exam cramming.</a:t>
-            </a:r>
-          </a:p>
-          <a:p>
-            <a:pPr>
-              <a:spcAft>
-                <a:spcPts val="400"/>
-              </a:spcAft>
-              <a:defRPr sz="1200">
-                <a:solidFill>
-                  <a:srgbClr val="A5AFBE"/>
-                </a:solidFill>
-                <a:latin typeface="Arial"/>
-              </a:defRPr>
-            </a:pPr>
-            <a:r>
-              <a:t>• Prescribes high-yield bulleted concept summaries with source quotes.</a:t>
+              <a:t>• Eliminates invalid test keys and erroneous study facts.</a:t>
             </a:r>
           </a:p>
         </p:txBody>
       </p:sp>
       <p:pic>
         <p:nvPicPr>
-          <p:cNvPr id="9" name="Picture 8" descr="08_hub_earth_selected_framed.png"/>
+          <p:cNvPr id="8" name="Picture 7" descr="06_quiz_live.png"/>
           <p:cNvPicPr>
             <a:picLocks noChangeAspect="1"/>
           </p:cNvPicPr>
@@ -5962,8 +5309,32 @@
         </p:blipFill>
         <p:spPr>
           <a:xfrm>
-            <a:off x="9144000" y="1645920"/>
-            <a:ext cx="2148840" cy="4754880"/>
+            <a:off x="6400800" y="1097280"/>
+            <a:ext cx="2560320" cy="5303520"/>
+          </a:xfrm>
+          <a:prstGeom prst="rect">
+            <a:avLst/>
+          </a:prstGeom>
+        </p:spPr>
+      </p:pic>
+      <p:pic>
+        <p:nvPicPr>
+          <p:cNvPr id="9" name="Picture 8" descr="07_quiz_checked.png"/>
+          <p:cNvPicPr>
+            <a:picLocks noChangeAspect="1"/>
+          </p:cNvPicPr>
+          <p:nvPr/>
+        </p:nvPicPr>
+        <p:blipFill>
+          <a:blip r:embed="rId3"/>
+          <a:stretch>
+            <a:fillRect/>
+          </a:stretch>
+        </p:blipFill>
+        <p:spPr>
+          <a:xfrm>
+            <a:off x="9235440" y="1097280"/>
+            <a:ext cx="2560320" cy="5303520"/>
           </a:xfrm>
           <a:prstGeom prst="rect">
             <a:avLst/>
@@ -6039,7 +5410,7 @@
         </p:nvSpPr>
         <p:spPr>
           <a:xfrm>
-            <a:off x="731520" y="411480"/>
+            <a:off x="731520" y="384048"/>
             <a:ext cx="3108960" cy="329184"/>
           </a:xfrm>
           <a:prstGeom prst="roundRect">
@@ -6081,7 +5452,7 @@
               </a:defRPr>
             </a:pPr>
             <a:r>
-              <a:t>05 · ACTIVE RECALL &amp; RETENTION</a:t>
+              <a:t>05 · INTERACTIVE TUTORING</a:t>
             </a:r>
           </a:p>
         </p:txBody>
@@ -6094,8 +5465,8 @@
         </p:nvSpPr>
         <p:spPr>
           <a:xfrm>
-            <a:off x="731520" y="804672"/>
-            <a:ext cx="10698480" cy="1051560"/>
+            <a:off x="731520" y="777240"/>
+            <a:ext cx="7498079" cy="1051560"/>
           </a:xfrm>
           <a:prstGeom prst="rect">
             <a:avLst/>
@@ -6117,7 +5488,7 @@
               </a:defRPr>
             </a:pPr>
             <a:r>
-              <a:t>Evidence-Grounded Flashcards with SuperMemo SM-2</a:t>
+              <a:t>Real-Time Academic Mentor in Airplane Mode</a:t>
             </a:r>
           </a:p>
           <a:p>
@@ -6133,7 +5504,7 @@
               </a:defRPr>
             </a:pPr>
             <a:r>
-              <a:t>Combines the gold-standard spaced repetition algorithm with zero-hallucination provenance.</a:t>
+              <a:t>On-device conversational AI explaining complex mechanisms on demand.</a:t>
             </a:r>
           </a:p>
         </p:txBody>
@@ -6147,7 +5518,7 @@
         <p:spPr>
           <a:xfrm>
             <a:off x="731520" y="2011680"/>
-            <a:ext cx="6217920" cy="1234440"/>
+            <a:ext cx="6766560" cy="1234440"/>
           </a:xfrm>
           <a:prstGeom prst="roundRect">
             <a:avLst/>
@@ -6176,14 +5547,14 @@
           </a:fontRef>
         </p:style>
         <p:txBody>
-          <a:bodyPr rtlCol="0" anchor="ctr" wrap="square" lIns="228600" rIns="228600" tIns="201168" bIns="201168"/>
+          <a:bodyPr rtlCol="0" anchor="ctr" wrap="square" lIns="228600" rIns="228600" tIns="182880" bIns="182880"/>
           <a:lstStyle/>
           <a:p>
             <a:pPr algn="ctr">
               <a:spcAft>
-                <a:spcPts val="800"/>
+                <a:spcPts val="600"/>
               </a:spcAft>
-              <a:defRPr sz="1500" b="1">
+              <a:defRPr sz="1400" b="1">
                 <a:solidFill>
                   <a:srgbClr val="FFFFFF"/>
                 </a:solidFill>
@@ -6191,15 +5562,15 @@
               </a:defRPr>
             </a:pPr>
             <a:r>
-              <a:t>🧠 SuperMemo SM-2 Spaced Repetition</a:t>
+              <a:t>🌍 Universal Multidisciplinary Grounding</a:t>
             </a:r>
           </a:p>
           <a:p>
             <a:pPr>
               <a:spcAft>
-                <a:spcPts val="400"/>
+                <a:spcPts val="300"/>
               </a:spcAft>
-              <a:defRPr sz="1200">
+              <a:defRPr sz="1150">
                 <a:solidFill>
                   <a:srgbClr val="A5AFBE"/>
                 </a:solidFill>
@@ -6207,15 +5578,15 @@
               </a:defRPr>
             </a:pPr>
             <a:r>
-              <a:t>• Automatically calculates ease factor (EF) and repetition intervals (I_n).</a:t>
+              <a:t>• Mentors across STEM, Calculus, Discrete Math, History, Rizal, Law, and Medicine.</a:t>
             </a:r>
           </a:p>
           <a:p>
             <a:pPr>
               <a:spcAft>
-                <a:spcPts val="400"/>
+                <a:spcPts val="300"/>
               </a:spcAft>
-              <a:defRPr sz="1200">
+              <a:defRPr sz="1150">
                 <a:solidFill>
                   <a:srgbClr val="A5AFBE"/>
                 </a:solidFill>
@@ -6223,7 +5594,7 @@
               </a:defRPr>
             </a:pPr>
             <a:r>
-              <a:t>• Self-evaluations: Again (1d), Hard (3d), Good (4d), Easy (6d) optimize permanent retention.</a:t>
+              <a:t>• Unpacks tough mechanisms with step-by-step conceptual walkthroughs.</a:t>
             </a:r>
           </a:p>
         </p:txBody>
@@ -6237,7 +5608,7 @@
         <p:spPr>
           <a:xfrm>
             <a:off x="731520" y="3383280"/>
-            <a:ext cx="6217920" cy="1234440"/>
+            <a:ext cx="6766560" cy="1234440"/>
           </a:xfrm>
           <a:prstGeom prst="roundRect">
             <a:avLst/>
@@ -6266,14 +5637,14 @@
           </a:fontRef>
         </p:style>
         <p:txBody>
-          <a:bodyPr rtlCol="0" anchor="ctr" wrap="square" lIns="228600" rIns="228600" tIns="201168" bIns="201168"/>
+          <a:bodyPr rtlCol="0" anchor="ctr" wrap="square" lIns="228600" rIns="228600" tIns="182880" bIns="182880"/>
           <a:lstStyle/>
           <a:p>
             <a:pPr algn="ctr">
               <a:spcAft>
-                <a:spcPts val="800"/>
+                <a:spcPts val="600"/>
               </a:spcAft>
-              <a:defRPr sz="1500" b="1">
+              <a:defRPr sz="1400" b="1">
                 <a:solidFill>
                   <a:srgbClr val="FFFFFF"/>
                 </a:solidFill>
@@ -6281,15 +5652,15 @@
               </a:defRPr>
             </a:pPr>
             <a:r>
-              <a:t>🚫 Strict Negative Prompt Constraints</a:t>
+              <a:t>📑 Rich Markdown &amp; Code Formatting</a:t>
             </a:r>
           </a:p>
           <a:p>
             <a:pPr>
               <a:spcAft>
-                <a:spcPts val="400"/>
+                <a:spcPts val="300"/>
               </a:spcAft>
-              <a:defRPr sz="1200">
+              <a:defRPr sz="1150">
                 <a:solidFill>
                   <a:srgbClr val="A5AFBE"/>
                 </a:solidFill>
@@ -6297,15 +5668,15 @@
               </a:defRPr>
             </a:pPr>
             <a:r>
-              <a:t>• Explicitly forbids generic meta-questions like 'What was the user intended to study?'.</a:t>
+              <a:t>• Native Jetpack Compose formatting with tables, bulleted lists, and formulas.</a:t>
             </a:r>
           </a:p>
           <a:p>
             <a:pPr>
               <a:spcAft>
-                <a:spcPts val="400"/>
+                <a:spcPts val="300"/>
               </a:spcAft>
-              <a:defRPr sz="1200">
+              <a:defRPr sz="1150">
                 <a:solidFill>
                   <a:srgbClr val="A5AFBE"/>
                 </a:solidFill>
@@ -6313,7 +5684,7 @@
               </a:defRPr>
             </a:pPr>
             <a:r>
-              <a:t>• Rigorously tests concrete academic terms: Mitochondria, ATP synthesis, cellular respiration.</a:t>
+              <a:t>• Clean visual hierarchy avoids overwhelming walls of plain text.</a:t>
             </a:r>
           </a:p>
         </p:txBody>
@@ -6327,7 +5698,7 @@
         <p:spPr>
           <a:xfrm>
             <a:off x="731520" y="4754880"/>
-            <a:ext cx="6217920" cy="1234440"/>
+            <a:ext cx="6766560" cy="1234440"/>
           </a:xfrm>
           <a:prstGeom prst="roundRect">
             <a:avLst/>
@@ -6356,14 +5727,14 @@
           </a:fontRef>
         </p:style>
         <p:txBody>
-          <a:bodyPr rtlCol="0" anchor="ctr" wrap="square" lIns="228600" rIns="228600" tIns="201168" bIns="201168"/>
+          <a:bodyPr rtlCol="0" anchor="ctr" wrap="square" lIns="228600" rIns="228600" tIns="182880" bIns="182880"/>
           <a:lstStyle/>
           <a:p>
             <a:pPr algn="ctr">
               <a:spcAft>
-                <a:spcPts val="800"/>
+                <a:spcPts val="600"/>
               </a:spcAft>
-              <a:defRPr sz="1500" b="1">
+              <a:defRPr sz="1400" b="1">
                 <a:solidFill>
                   <a:srgbClr val="FFFFFF"/>
                 </a:solidFill>
@@ -6371,15 +5742,15 @@
               </a:defRPr>
             </a:pPr>
             <a:r>
-              <a:t>📖 Verbatim Evidence &amp; Source Grounding</a:t>
+              <a:t>💾 Multi-Session Local Memory &amp; Tabs</a:t>
             </a:r>
           </a:p>
           <a:p>
             <a:pPr>
               <a:spcAft>
-                <a:spcPts val="400"/>
+                <a:spcPts val="300"/>
               </a:spcAft>
-              <a:defRPr sz="1200">
+              <a:defRPr sz="1150">
                 <a:solidFill>
                   <a:srgbClr val="A5AFBE"/>
                 </a:solidFill>
@@ -6387,15 +5758,15 @@
               </a:defRPr>
             </a:pPr>
             <a:r>
-              <a:t>• Card back highlights verbatim source sentences and section provenance tags.</a:t>
+              <a:t>• Conversation history persisted securely on device with quick topic tabs.</a:t>
             </a:r>
           </a:p>
           <a:p>
             <a:pPr>
               <a:spcAft>
-                <a:spcPts val="400"/>
+                <a:spcPts val="300"/>
               </a:spcAft>
-              <a:defRPr sz="1200">
+              <a:defRPr sz="1150">
                 <a:solidFill>
                   <a:srgbClr val="A5AFBE"/>
                 </a:solidFill>
@@ -6403,14 +5774,14 @@
               </a:defRPr>
             </a:pPr>
             <a:r>
-              <a:t>• Guarantees 100% accurate studying without fabricated AI hallucinations.</a:t>
+              <a:t>• Complete data privacy: student questions never leave device memory.</a:t>
             </a:r>
           </a:p>
         </p:txBody>
       </p:sp>
       <p:pic>
         <p:nvPicPr>
-          <p:cNvPr id="8" name="Picture 7" descr="09_flashcard_question_framed.png"/>
+          <p:cNvPr id="8" name="Picture 7" descr="08_chat.png"/>
           <p:cNvPicPr>
             <a:picLocks noChangeAspect="1"/>
           </p:cNvPicPr>
@@ -6424,32 +5795,8 @@
         </p:blipFill>
         <p:spPr>
           <a:xfrm>
-            <a:off x="7315200" y="1645920"/>
-            <a:ext cx="2103120" cy="4754880"/>
-          </a:xfrm>
-          <a:prstGeom prst="rect">
-            <a:avLst/>
-          </a:prstGeom>
-        </p:spPr>
-      </p:pic>
-      <p:pic>
-        <p:nvPicPr>
-          <p:cNvPr id="9" name="Picture 8" descr="10_flashcard_answer_framed.png"/>
-          <p:cNvPicPr>
-            <a:picLocks noChangeAspect="1"/>
-          </p:cNvPicPr>
-          <p:nvPr/>
-        </p:nvPicPr>
-        <p:blipFill>
-          <a:blip r:embed="rId3"/>
-          <a:stretch>
-            <a:fillRect/>
-          </a:stretch>
-        </p:blipFill>
-        <p:spPr>
-          <a:xfrm>
-            <a:off x="9601200" y="1645920"/>
-            <a:ext cx="2103120" cy="4754880"/>
+            <a:off x="8412480" y="1097280"/>
+            <a:ext cx="2606040" cy="5349240"/>
           </a:xfrm>
           <a:prstGeom prst="rect">
             <a:avLst/>
@@ -6525,7 +5872,7 @@
         </p:nvSpPr>
         <p:spPr>
           <a:xfrm>
-            <a:off x="731520" y="411480"/>
+            <a:off x="731520" y="384048"/>
             <a:ext cx="3108960" cy="329184"/>
           </a:xfrm>
           <a:prstGeom prst="roundRect">
@@ -6567,7 +5914,7 @@
               </a:defRPr>
             </a:pPr>
             <a:r>
-              <a:t>06 · EXAM PREPARATION</a:t>
+              <a:t>06 · ARCHITECTURE &amp; ROADMAP</a:t>
             </a:r>
           </a:p>
         </p:txBody>
@@ -6580,8 +5927,8 @@
         </p:nvSpPr>
         <p:spPr>
           <a:xfrm>
-            <a:off x="731520" y="804672"/>
-            <a:ext cx="10698480" cy="1051560"/>
+            <a:off x="731520" y="777240"/>
+            <a:ext cx="7498079" cy="1051560"/>
           </a:xfrm>
           <a:prstGeom prst="rect">
             <a:avLst/>
@@ -6603,7 +5950,7 @@
               </a:defRPr>
             </a:pPr>
             <a:r>
-              <a:t>High-Yield Reviewers &amp; Verified Practice Quizzes</a:t>
+              <a:t>Engineered for Performance, Ready to Deploy</a:t>
             </a:r>
           </a:p>
           <a:p>
@@ -6619,7 +5966,7 @@
               </a:defRPr>
             </a:pPr>
             <a:r>
-              <a:t>Synthesizes complex notes into structured study sheets and scored assessments.</a:t>
+              <a:t>Native Android architecture powered by Google LiteRT-LM and open-source delivery.</a:t>
             </a:r>
           </a:p>
         </p:txBody>
@@ -6633,7 +5980,7 @@
         <p:spPr>
           <a:xfrm>
             <a:off x="731520" y="2011680"/>
-            <a:ext cx="6217920" cy="1234440"/>
+            <a:ext cx="6766560" cy="1234440"/>
           </a:xfrm>
           <a:prstGeom prst="roundRect">
             <a:avLst/>
@@ -6662,14 +6009,14 @@
           </a:fontRef>
         </p:style>
         <p:txBody>
-          <a:bodyPr rtlCol="0" anchor="ctr" wrap="square" lIns="228600" rIns="228600" tIns="201168" bIns="201168"/>
+          <a:bodyPr rtlCol="0" anchor="ctr" wrap="square" lIns="228600" rIns="228600" tIns="182880" bIns="182880"/>
           <a:lstStyle/>
           <a:p>
             <a:pPr algn="ctr">
               <a:spcAft>
-                <a:spcPts val="800"/>
+                <a:spcPts val="600"/>
               </a:spcAft>
-              <a:defRPr sz="1500" b="1">
+              <a:defRPr sz="1400" b="1">
                 <a:solidFill>
                   <a:srgbClr val="FFFFFF"/>
                 </a:solidFill>
@@ -6677,15 +6024,15 @@
               </a:defRPr>
             </a:pPr>
             <a:r>
-              <a:t>📝 High-Yield Topic Synthesis</a:t>
+              <a:t>🤖 Google LiteRT-LM &amp; Gemma 4 E2B</a:t>
             </a:r>
           </a:p>
           <a:p>
             <a:pPr>
               <a:spcAft>
-                <a:spcPts val="400"/>
+                <a:spcPts val="300"/>
               </a:spcAft>
-              <a:defRPr sz="1200">
+              <a:defRPr sz="1150">
                 <a:solidFill>
                   <a:srgbClr val="A5AFBE"/>
                 </a:solidFill>
@@ -6693,15 +6040,15 @@
               </a:defRPr>
             </a:pPr>
             <a:r>
-              <a:t>• Organizes dense textbook chapters into bulleted key principles, classifications, and definitions.</a:t>
+              <a:t>• Quantized 2.4 GB weights executed on-device with OpenCL / Adreno GPU acceleration.</a:t>
             </a:r>
           </a:p>
           <a:p>
             <a:pPr>
               <a:spcAft>
-                <a:spcPts val="400"/>
+                <a:spcPts val="300"/>
               </a:spcAft>
-              <a:defRPr sz="1200">
+              <a:defRPr sz="1150">
                 <a:solidFill>
                   <a:srgbClr val="A5AFBE"/>
                 </a:solidFill>
@@ -6709,7 +6056,7 @@
               </a:defRPr>
             </a:pPr>
             <a:r>
-              <a:t>• Ideal for rapid revision before major prelim, midterm, and board examinations.</a:t>
+              <a:t>• Sub-second latency with smooth streaming generation entirely offline.</a:t>
             </a:r>
           </a:p>
         </p:txBody>
@@ -6723,7 +6070,7 @@
         <p:spPr>
           <a:xfrm>
             <a:off x="731520" y="3383280"/>
-            <a:ext cx="6217920" cy="1234440"/>
+            <a:ext cx="6766560" cy="1234440"/>
           </a:xfrm>
           <a:prstGeom prst="roundRect">
             <a:avLst/>
@@ -6752,14 +6099,14 @@
           </a:fontRef>
         </p:style>
         <p:txBody>
-          <a:bodyPr rtlCol="0" anchor="ctr" wrap="square" lIns="228600" rIns="228600" tIns="201168" bIns="201168"/>
+          <a:bodyPr rtlCol="0" anchor="ctr" wrap="square" lIns="228600" rIns="228600" tIns="182880" bIns="182880"/>
           <a:lstStyle/>
           <a:p>
             <a:pPr algn="ctr">
               <a:spcAft>
-                <a:spcPts val="800"/>
+                <a:spcPts val="600"/>
               </a:spcAft>
-              <a:defRPr sz="1500" b="1">
+              <a:defRPr sz="1400" b="1">
                 <a:solidFill>
                   <a:srgbClr val="FFFFFF"/>
                 </a:solidFill>
@@ -6767,15 +6114,15 @@
               </a:defRPr>
             </a:pPr>
             <a:r>
-              <a:t>🏷️ Provenance &amp; Verifiability Badges</a:t>
+              <a:t>🎨 Native Jetpack Compose &amp; Offline Room DB</a:t>
             </a:r>
           </a:p>
           <a:p>
             <a:pPr>
               <a:spcAft>
-                <a:spcPts val="400"/>
+                <a:spcPts val="300"/>
               </a:spcAft>
-              <a:defRPr sz="1200">
+              <a:defRPr sz="1150">
                 <a:solidFill>
                   <a:srgbClr val="A5AFBE"/>
                 </a:solidFill>
@@ -6783,15 +6130,15 @@
               </a:defRPr>
             </a:pPr>
             <a:r>
-              <a:t>• Cites exact source sentences for every generated key concept.</a:t>
+              <a:t>• 100% modern Kotlin with Material 3 and packaged typography (Calibri, Serif, Mono).</a:t>
             </a:r>
           </a:p>
           <a:p>
             <a:pPr>
               <a:spcAft>
-                <a:spcPts val="400"/>
+                <a:spcPts val="300"/>
               </a:spcAft>
-              <a:defRPr sz="1200">
+              <a:defRPr sz="1150">
                 <a:solidFill>
                   <a:srgbClr val="A5AFBE"/>
                 </a:solidFill>
@@ -6799,7 +6146,7 @@
               </a:defRPr>
             </a:pPr>
             <a:r>
-              <a:t>• External facts added by the model are visibly marked [unverified] for complete transparency.</a:t>
+              <a:t>• Offline OCR via ML Kit v2 and pure local PDF ingestion.</a:t>
             </a:r>
           </a:p>
         </p:txBody>
@@ -6813,7 +6160,7 @@
         <p:spPr>
           <a:xfrm>
             <a:off x="731520" y="4754880"/>
-            <a:ext cx="6217920" cy="1234440"/>
+            <a:ext cx="6766560" cy="1234440"/>
           </a:xfrm>
           <a:prstGeom prst="roundRect">
             <a:avLst/>
@@ -6842,14 +6189,14 @@
           </a:fontRef>
         </p:style>
         <p:txBody>
-          <a:bodyPr rtlCol="0" anchor="ctr" wrap="square" lIns="228600" rIns="228600" tIns="201168" bIns="201168"/>
+          <a:bodyPr rtlCol="0" anchor="ctr" wrap="square" lIns="228600" rIns="228600" tIns="182880" bIns="182880"/>
           <a:lstStyle/>
           <a:p>
             <a:pPr algn="ctr">
               <a:spcAft>
-                <a:spcPts val="800"/>
+                <a:spcPts val="600"/>
               </a:spcAft>
-              <a:defRPr sz="1500" b="1">
+              <a:defRPr sz="1400" b="1">
                 <a:solidFill>
                   <a:srgbClr val="FFFFFF"/>
                 </a:solidFill>
@@ -6857,15 +6204,15 @@
               </a:defRPr>
             </a:pPr>
             <a:r>
-              <a:t>🎯 Multiple-Choice Exam Practice</a:t>
+              <a:t>📲 Shipped MVP &amp; Public GitHub Distribution</a:t>
             </a:r>
           </a:p>
           <a:p>
             <a:pPr>
               <a:spcAft>
-                <a:spcPts val="400"/>
+                <a:spcPts val="300"/>
               </a:spcAft>
-              <a:defRPr sz="1200">
+              <a:defRPr sz="1150">
                 <a:solidFill>
                   <a:srgbClr val="A5AFBE"/>
                 </a:solidFill>
@@ -6873,15 +6220,15 @@
               </a:defRPr>
             </a:pPr>
             <a:r>
-              <a:t>• Generates rigorous 4-option MCQs testing conceptual understanding.</a:t>
+              <a:t>• Verified on Android 14 hardware (OPPO Reno12 F 5G).</a:t>
             </a:r>
           </a:p>
           <a:p>
             <a:pPr>
               <a:spcAft>
-                <a:spcPts val="400"/>
+                <a:spcPts val="300"/>
               </a:spcAft>
-              <a:defRPr sz="1200">
+              <a:defRPr sz="1150">
                 <a:solidFill>
                   <a:srgbClr val="A5AFBE"/>
                 </a:solidFill>
@@ -6889,14 +6236,14 @@
               </a:defRPr>
             </a:pPr>
             <a:r>
-              <a:t>• Instant grading with detailed explanations on why distractor options are incorrect.</a:t>
+              <a:t>• Public Repository: github.com/meloervy/appbuild.gemce with installable APK.</a:t>
             </a:r>
           </a:p>
         </p:txBody>
       </p:sp>
       <p:pic>
         <p:nvPicPr>
-          <p:cNvPr id="8" name="Picture 7" descr="12_mcq_quiz_framed.png"/>
+          <p:cNvPr id="8" name="Picture 7" descr="09_about.png"/>
           <p:cNvPicPr>
             <a:picLocks noChangeAspect="1"/>
           </p:cNvPicPr>
@@ -6910,1156 +6257,14 @@
         </p:blipFill>
         <p:spPr>
           <a:xfrm>
-            <a:off x="7315200" y="1645920"/>
-            <a:ext cx="2103120" cy="4754880"/>
+            <a:off x="8412480" y="1097280"/>
+            <a:ext cx="2606040" cy="5349240"/>
           </a:xfrm>
           <a:prstGeom prst="rect">
             <a:avLst/>
           </a:prstGeom>
         </p:spPr>
       </p:pic>
-      <p:pic>
-        <p:nvPicPr>
-          <p:cNvPr id="9" name="Picture 8" descr="12_reviewer_active_framed.png"/>
-          <p:cNvPicPr>
-            <a:picLocks noChangeAspect="1"/>
-          </p:cNvPicPr>
-          <p:nvPr/>
-        </p:nvPicPr>
-        <p:blipFill>
-          <a:blip r:embed="rId3"/>
-          <a:stretch>
-            <a:fillRect/>
-          </a:stretch>
-        </p:blipFill>
-        <p:spPr>
-          <a:xfrm>
-            <a:off x="9601200" y="1645920"/>
-            <a:ext cx="2103120" cy="4754880"/>
-          </a:xfrm>
-          <a:prstGeom prst="rect">
-            <a:avLst/>
-          </a:prstGeom>
-        </p:spPr>
-      </p:pic>
-    </p:spTree>
-  </p:cSld>
-  <p:clrMapOvr>
-    <a:masterClrMapping/>
-  </p:clrMapOvr>
-</p:sld>
-</file>
-
-<file path=ppt/slides/slide8.xml><?xml version="1.0" encoding="utf-8"?>
-<p:sld xmlns:a="http://schemas.openxmlformats.org/drawingml/2006/main" xmlns:p="http://schemas.openxmlformats.org/presentationml/2006/main" xmlns:r="http://schemas.openxmlformats.org/officeDocument/2006/relationships">
-  <p:cSld>
-    <p:spTree>
-      <p:nvGrpSpPr>
-        <p:cNvPr id="1" name=""/>
-        <p:cNvGrpSpPr/>
-        <p:nvPr/>
-      </p:nvGrpSpPr>
-      <p:grpSpPr/>
-      <p:sp>
-        <p:nvSpPr>
-          <p:cNvPr id="2" name="Rectangle 1"/>
-          <p:cNvSpPr/>
-          <p:nvPr/>
-        </p:nvSpPr>
-        <p:spPr>
-          <a:xfrm>
-            <a:off x="0" y="0"/>
-            <a:ext cx="12191695" cy="6858000"/>
-          </a:xfrm>
-          <a:prstGeom prst="rect">
-            <a:avLst/>
-          </a:prstGeom>
-          <a:solidFill>
-            <a:srgbClr val="0E1015"/>
-          </a:solidFill>
-          <a:ln>
-            <a:noFill/>
-          </a:ln>
-        </p:spPr>
-        <p:style>
-          <a:lnRef idx="1">
-            <a:schemeClr val="accent1"/>
-          </a:lnRef>
-          <a:fillRef idx="3">
-            <a:schemeClr val="accent1"/>
-          </a:fillRef>
-          <a:effectRef idx="2">
-            <a:schemeClr val="accent1"/>
-          </a:effectRef>
-          <a:fontRef idx="minor">
-            <a:schemeClr val="lt1"/>
-          </a:fontRef>
-        </p:style>
-        <p:txBody>
-          <a:bodyPr rtlCol="0" anchor="ctr"/>
-          <a:lstStyle/>
-          <a:p>
-            <a:pPr algn="ctr"/>
-          </a:p>
-        </p:txBody>
-      </p:sp>
-      <p:sp>
-        <p:nvSpPr>
-          <p:cNvPr id="3" name="Rounded Rectangle 2"/>
-          <p:cNvSpPr/>
-          <p:nvPr/>
-        </p:nvSpPr>
-        <p:spPr>
-          <a:xfrm>
-            <a:off x="731520" y="411480"/>
-            <a:ext cx="3108960" cy="329184"/>
-          </a:xfrm>
-          <a:prstGeom prst="roundRect">
-            <a:avLst/>
-          </a:prstGeom>
-          <a:solidFill>
-            <a:srgbClr val="162D22"/>
-          </a:solidFill>
-          <a:ln w="12700">
-            <a:solidFill>
-              <a:srgbClr val="3DDC84"/>
-            </a:solidFill>
-          </a:ln>
-        </p:spPr>
-        <p:style>
-          <a:lnRef idx="1">
-            <a:schemeClr val="accent1"/>
-          </a:lnRef>
-          <a:fillRef idx="3">
-            <a:schemeClr val="accent1"/>
-          </a:fillRef>
-          <a:effectRef idx="2">
-            <a:schemeClr val="accent1"/>
-          </a:effectRef>
-          <a:fontRef idx="minor">
-            <a:schemeClr val="lt1"/>
-          </a:fontRef>
-        </p:style>
-        <p:txBody>
-          <a:bodyPr rtlCol="0" anchor="ctr" wrap="none" lIns="0" rIns="0" tIns="0" bIns="0"/>
-          <a:lstStyle/>
-          <a:p>
-            <a:pPr algn="ctr">
-              <a:defRPr sz="1000" b="1">
-                <a:solidFill>
-                  <a:srgbClr val="3DDC84"/>
-                </a:solidFill>
-                <a:latin typeface="Arial"/>
-              </a:defRPr>
-            </a:pPr>
-            <a:r>
-              <a:t>07 · INTERACTIVE TUTORING</a:t>
-            </a:r>
-          </a:p>
-        </p:txBody>
-      </p:sp>
-      <p:sp>
-        <p:nvSpPr>
-          <p:cNvPr id="4" name="TextBox 3"/>
-          <p:cNvSpPr txBox="1"/>
-          <p:nvPr/>
-        </p:nvSpPr>
-        <p:spPr>
-          <a:xfrm>
-            <a:off x="731520" y="804672"/>
-            <a:ext cx="10698480" cy="1051560"/>
-          </a:xfrm>
-          <a:prstGeom prst="rect">
-            <a:avLst/>
-          </a:prstGeom>
-          <a:noFill/>
-        </p:spPr>
-        <p:txBody>
-          <a:bodyPr wrap="square" lIns="0" rIns="0" tIns="0" bIns="0">
-            <a:spAutoFit/>
-          </a:bodyPr>
-          <a:lstStyle/>
-          <a:p>
-            <a:pPr>
-              <a:defRPr sz="2500" b="1">
-                <a:solidFill>
-                  <a:srgbClr val="FFFFFF"/>
-                </a:solidFill>
-                <a:latin typeface="Arial"/>
-              </a:defRPr>
-            </a:pPr>
-            <a:r>
-              <a:t>Real-Time Conceptual Q&amp;A in Airplane Mode</a:t>
-            </a:r>
-          </a:p>
-          <a:p>
-            <a:pPr>
-              <a:spcBef>
-                <a:spcPts val="400"/>
-              </a:spcBef>
-              <a:defRPr sz="1300">
-                <a:solidFill>
-                  <a:srgbClr val="A5AFBE"/>
-                </a:solidFill>
-                <a:latin typeface="Arial"/>
-              </a:defRPr>
-            </a:pPr>
-            <a:r>
-              <a:t>Interactive academic mentor explaining tough mechanisms whenever curiosity strikes.</a:t>
-            </a:r>
-          </a:p>
-        </p:txBody>
-      </p:sp>
-      <p:sp>
-        <p:nvSpPr>
-          <p:cNvPr id="5" name="Rounded Rectangle 4"/>
-          <p:cNvSpPr/>
-          <p:nvPr/>
-        </p:nvSpPr>
-        <p:spPr>
-          <a:xfrm>
-            <a:off x="731520" y="2011680"/>
-            <a:ext cx="7863840" cy="1234440"/>
-          </a:xfrm>
-          <a:prstGeom prst="roundRect">
-            <a:avLst/>
-          </a:prstGeom>
-          <a:solidFill>
-            <a:srgbClr val="181B24"/>
-          </a:solidFill>
-          <a:ln w="12700">
-            <a:solidFill>
-              <a:srgbClr val="2E3546"/>
-            </a:solidFill>
-          </a:ln>
-        </p:spPr>
-        <p:style>
-          <a:lnRef idx="1">
-            <a:schemeClr val="accent1"/>
-          </a:lnRef>
-          <a:fillRef idx="3">
-            <a:schemeClr val="accent1"/>
-          </a:fillRef>
-          <a:effectRef idx="2">
-            <a:schemeClr val="accent1"/>
-          </a:effectRef>
-          <a:fontRef idx="minor">
-            <a:schemeClr val="lt1"/>
-          </a:fontRef>
-        </p:style>
-        <p:txBody>
-          <a:bodyPr rtlCol="0" anchor="ctr" wrap="square" lIns="228600" rIns="228600" tIns="201168" bIns="201168"/>
-          <a:lstStyle/>
-          <a:p>
-            <a:pPr algn="ctr">
-              <a:spcAft>
-                <a:spcPts val="800"/>
-              </a:spcAft>
-              <a:defRPr sz="1500" b="1">
-                <a:solidFill>
-                  <a:srgbClr val="FFFFFF"/>
-                </a:solidFill>
-                <a:latin typeface="Arial"/>
-              </a:defRPr>
-            </a:pPr>
-            <a:r>
-              <a:t>🌍 Universal Multidisciplinary Grounding</a:t>
-            </a:r>
-          </a:p>
-          <a:p>
-            <a:pPr>
-              <a:spcAft>
-                <a:spcPts val="400"/>
-              </a:spcAft>
-              <a:defRPr sz="1200">
-                <a:solidFill>
-                  <a:srgbClr val="A5AFBE"/>
-                </a:solidFill>
-                <a:latin typeface="Arial"/>
-              </a:defRPr>
-            </a:pPr>
-            <a:r>
-              <a:t>• Mentors across Natural Sciences, Discrete Mathematics, World History, Rizal, Law, and Medicine.</a:t>
-            </a:r>
-          </a:p>
-          <a:p>
-            <a:pPr>
-              <a:spcAft>
-                <a:spcPts val="400"/>
-              </a:spcAft>
-              <a:defRPr sz="1200">
-                <a:solidFill>
-                  <a:srgbClr val="A5AFBE"/>
-                </a:solidFill>
-                <a:latin typeface="Arial"/>
-              </a:defRPr>
-            </a:pPr>
-            <a:r>
-              <a:t>• Resolves complex queries: e.g. rock cycle mechanisms, truth tables, and historical contexts.</a:t>
-            </a:r>
-          </a:p>
-        </p:txBody>
-      </p:sp>
-      <p:sp>
-        <p:nvSpPr>
-          <p:cNvPr id="6" name="Rounded Rectangle 5"/>
-          <p:cNvSpPr/>
-          <p:nvPr/>
-        </p:nvSpPr>
-        <p:spPr>
-          <a:xfrm>
-            <a:off x="731520" y="3383280"/>
-            <a:ext cx="7863840" cy="1234440"/>
-          </a:xfrm>
-          <a:prstGeom prst="roundRect">
-            <a:avLst/>
-          </a:prstGeom>
-          <a:solidFill>
-            <a:srgbClr val="181B24"/>
-          </a:solidFill>
-          <a:ln w="12700">
-            <a:solidFill>
-              <a:srgbClr val="2E3546"/>
-            </a:solidFill>
-          </a:ln>
-        </p:spPr>
-        <p:style>
-          <a:lnRef idx="1">
-            <a:schemeClr val="accent1"/>
-          </a:lnRef>
-          <a:fillRef idx="3">
-            <a:schemeClr val="accent1"/>
-          </a:fillRef>
-          <a:effectRef idx="2">
-            <a:schemeClr val="accent1"/>
-          </a:effectRef>
-          <a:fontRef idx="minor">
-            <a:schemeClr val="lt1"/>
-          </a:fontRef>
-        </p:style>
-        <p:txBody>
-          <a:bodyPr rtlCol="0" anchor="ctr" wrap="square" lIns="228600" rIns="228600" tIns="201168" bIns="201168"/>
-          <a:lstStyle/>
-          <a:p>
-            <a:pPr algn="ctr">
-              <a:spcAft>
-                <a:spcPts val="800"/>
-              </a:spcAft>
-              <a:defRPr sz="1500" b="1">
-                <a:solidFill>
-                  <a:srgbClr val="FFFFFF"/>
-                </a:solidFill>
-                <a:latin typeface="Arial"/>
-              </a:defRPr>
-            </a:pPr>
-            <a:r>
-              <a:t>📑 Rich Markdown &amp; Code Formatting</a:t>
-            </a:r>
-          </a:p>
-          <a:p>
-            <a:pPr>
-              <a:spcAft>
-                <a:spcPts val="400"/>
-              </a:spcAft>
-              <a:defRPr sz="1200">
-                <a:solidFill>
-                  <a:srgbClr val="A5AFBE"/>
-                </a:solidFill>
-                <a:latin typeface="Arial"/>
-              </a:defRPr>
-            </a:pPr>
-            <a:r>
-              <a:t>• Native Jetpack Compose Markdown rendering with formatted tables, lists, and KaTeX math formulas.</a:t>
-            </a:r>
-          </a:p>
-          <a:p>
-            <a:pPr>
-              <a:spcAft>
-                <a:spcPts val="400"/>
-              </a:spcAft>
-              <a:defRPr sz="1200">
-                <a:solidFill>
-                  <a:srgbClr val="A5AFBE"/>
-                </a:solidFill>
-                <a:latin typeface="Arial"/>
-              </a:defRPr>
-            </a:pPr>
-            <a:r>
-              <a:t>• Clean visual hierarchy avoids walls of unstructured text.</a:t>
-            </a:r>
-          </a:p>
-        </p:txBody>
-      </p:sp>
-      <p:sp>
-        <p:nvSpPr>
-          <p:cNvPr id="7" name="Rounded Rectangle 6"/>
-          <p:cNvSpPr/>
-          <p:nvPr/>
-        </p:nvSpPr>
-        <p:spPr>
-          <a:xfrm>
-            <a:off x="731520" y="4754880"/>
-            <a:ext cx="7863840" cy="1234440"/>
-          </a:xfrm>
-          <a:prstGeom prst="roundRect">
-            <a:avLst/>
-          </a:prstGeom>
-          <a:solidFill>
-            <a:srgbClr val="181B24"/>
-          </a:solidFill>
-          <a:ln w="12700">
-            <a:solidFill>
-              <a:srgbClr val="2E3546"/>
-            </a:solidFill>
-          </a:ln>
-        </p:spPr>
-        <p:style>
-          <a:lnRef idx="1">
-            <a:schemeClr val="accent1"/>
-          </a:lnRef>
-          <a:fillRef idx="3">
-            <a:schemeClr val="accent1"/>
-          </a:fillRef>
-          <a:effectRef idx="2">
-            <a:schemeClr val="accent1"/>
-          </a:effectRef>
-          <a:fontRef idx="minor">
-            <a:schemeClr val="lt1"/>
-          </a:fontRef>
-        </p:style>
-        <p:txBody>
-          <a:bodyPr rtlCol="0" anchor="ctr" wrap="square" lIns="228600" rIns="228600" tIns="201168" bIns="201168"/>
-          <a:lstStyle/>
-          <a:p>
-            <a:pPr algn="ctr">
-              <a:spcAft>
-                <a:spcPts val="800"/>
-              </a:spcAft>
-              <a:defRPr sz="1500" b="1">
-                <a:solidFill>
-                  <a:srgbClr val="FFFFFF"/>
-                </a:solidFill>
-                <a:latin typeface="Arial"/>
-              </a:defRPr>
-            </a:pPr>
-            <a:r>
-              <a:t>💾 Multi-Session Local Memory &amp; Tabs</a:t>
-            </a:r>
-          </a:p>
-          <a:p>
-            <a:pPr>
-              <a:spcAft>
-                <a:spcPts val="400"/>
-              </a:spcAft>
-              <a:defRPr sz="1200">
-                <a:solidFill>
-                  <a:srgbClr val="A5AFBE"/>
-                </a:solidFill>
-                <a:latin typeface="Arial"/>
-              </a:defRPr>
-            </a:pPr>
-            <a:r>
-              <a:t>• Conversation history persisted securely on device with quick topic tabs.</a:t>
-            </a:r>
-          </a:p>
-          <a:p>
-            <a:pPr>
-              <a:spcAft>
-                <a:spcPts val="400"/>
-              </a:spcAft>
-              <a:defRPr sz="1200">
-                <a:solidFill>
-                  <a:srgbClr val="A5AFBE"/>
-                </a:solidFill>
-                <a:latin typeface="Arial"/>
-              </a:defRPr>
-            </a:pPr>
-            <a:r>
-              <a:t>• Zero cloud leakage: student inquiries never leave device memory.</a:t>
-            </a:r>
-          </a:p>
-        </p:txBody>
-      </p:sp>
-      <p:pic>
-        <p:nvPicPr>
-          <p:cNvPr id="8" name="Picture 7" descr="14_chat_response_framed.png"/>
-          <p:cNvPicPr>
-            <a:picLocks noChangeAspect="1"/>
-          </p:cNvPicPr>
-          <p:nvPr/>
-        </p:nvPicPr>
-        <p:blipFill>
-          <a:blip r:embed="rId2"/>
-          <a:stretch>
-            <a:fillRect/>
-          </a:stretch>
-        </p:blipFill>
-        <p:spPr>
-          <a:xfrm>
-            <a:off x="9144000" y="1645920"/>
-            <a:ext cx="2148840" cy="4754880"/>
-          </a:xfrm>
-          <a:prstGeom prst="rect">
-            <a:avLst/>
-          </a:prstGeom>
-        </p:spPr>
-      </p:pic>
-    </p:spTree>
-  </p:cSld>
-  <p:clrMapOvr>
-    <a:masterClrMapping/>
-  </p:clrMapOvr>
-</p:sld>
-</file>
-
-<file path=ppt/slides/slide9.xml><?xml version="1.0" encoding="utf-8"?>
-<p:sld xmlns:a="http://schemas.openxmlformats.org/drawingml/2006/main" xmlns:p="http://schemas.openxmlformats.org/presentationml/2006/main" xmlns:r="http://schemas.openxmlformats.org/officeDocument/2006/relationships">
-  <p:cSld>
-    <p:spTree>
-      <p:nvGrpSpPr>
-        <p:cNvPr id="1" name=""/>
-        <p:cNvGrpSpPr/>
-        <p:nvPr/>
-      </p:nvGrpSpPr>
-      <p:grpSpPr/>
-      <p:sp>
-        <p:nvSpPr>
-          <p:cNvPr id="2" name="Rectangle 1"/>
-          <p:cNvSpPr/>
-          <p:nvPr/>
-        </p:nvSpPr>
-        <p:spPr>
-          <a:xfrm>
-            <a:off x="0" y="0"/>
-            <a:ext cx="12191695" cy="6858000"/>
-          </a:xfrm>
-          <a:prstGeom prst="rect">
-            <a:avLst/>
-          </a:prstGeom>
-          <a:solidFill>
-            <a:srgbClr val="0E1015"/>
-          </a:solidFill>
-          <a:ln>
-            <a:noFill/>
-          </a:ln>
-        </p:spPr>
-        <p:style>
-          <a:lnRef idx="1">
-            <a:schemeClr val="accent1"/>
-          </a:lnRef>
-          <a:fillRef idx="3">
-            <a:schemeClr val="accent1"/>
-          </a:fillRef>
-          <a:effectRef idx="2">
-            <a:schemeClr val="accent1"/>
-          </a:effectRef>
-          <a:fontRef idx="minor">
-            <a:schemeClr val="lt1"/>
-          </a:fontRef>
-        </p:style>
-        <p:txBody>
-          <a:bodyPr rtlCol="0" anchor="ctr"/>
-          <a:lstStyle/>
-          <a:p>
-            <a:pPr algn="ctr"/>
-          </a:p>
-        </p:txBody>
-      </p:sp>
-      <p:sp>
-        <p:nvSpPr>
-          <p:cNvPr id="3" name="Rounded Rectangle 2"/>
-          <p:cNvSpPr/>
-          <p:nvPr/>
-        </p:nvSpPr>
-        <p:spPr>
-          <a:xfrm>
-            <a:off x="731520" y="411480"/>
-            <a:ext cx="3108960" cy="329184"/>
-          </a:xfrm>
-          <a:prstGeom prst="roundRect">
-            <a:avLst/>
-          </a:prstGeom>
-          <a:solidFill>
-            <a:srgbClr val="162D22"/>
-          </a:solidFill>
-          <a:ln w="12700">
-            <a:solidFill>
-              <a:srgbClr val="3DDC84"/>
-            </a:solidFill>
-          </a:ln>
-        </p:spPr>
-        <p:style>
-          <a:lnRef idx="1">
-            <a:schemeClr val="accent1"/>
-          </a:lnRef>
-          <a:fillRef idx="3">
-            <a:schemeClr val="accent1"/>
-          </a:fillRef>
-          <a:effectRef idx="2">
-            <a:schemeClr val="accent1"/>
-          </a:effectRef>
-          <a:fontRef idx="minor">
-            <a:schemeClr val="lt1"/>
-          </a:fontRef>
-        </p:style>
-        <p:txBody>
-          <a:bodyPr rtlCol="0" anchor="ctr" wrap="none" lIns="0" rIns="0" tIns="0" bIns="0"/>
-          <a:lstStyle/>
-          <a:p>
-            <a:pPr algn="ctr">
-              <a:defRPr sz="1000" b="1">
-                <a:solidFill>
-                  <a:srgbClr val="3DDC84"/>
-                </a:solidFill>
-                <a:latin typeface="Arial"/>
-              </a:defRPr>
-            </a:pPr>
-            <a:r>
-              <a:t>08 · ENGINEERING &amp; TECH STACK</a:t>
-            </a:r>
-          </a:p>
-        </p:txBody>
-      </p:sp>
-      <p:sp>
-        <p:nvSpPr>
-          <p:cNvPr id="4" name="TextBox 3"/>
-          <p:cNvSpPr txBox="1"/>
-          <p:nvPr/>
-        </p:nvSpPr>
-        <p:spPr>
-          <a:xfrm>
-            <a:off x="731520" y="804672"/>
-            <a:ext cx="10698480" cy="1051560"/>
-          </a:xfrm>
-          <a:prstGeom prst="rect">
-            <a:avLst/>
-          </a:prstGeom>
-          <a:noFill/>
-        </p:spPr>
-        <p:txBody>
-          <a:bodyPr wrap="square" lIns="0" rIns="0" tIns="0" bIns="0">
-            <a:spAutoFit/>
-          </a:bodyPr>
-          <a:lstStyle/>
-          <a:p>
-            <a:pPr>
-              <a:defRPr sz="2500" b="1">
-                <a:solidFill>
-                  <a:srgbClr val="FFFFFF"/>
-                </a:solidFill>
-                <a:latin typeface="Arial"/>
-              </a:defRPr>
-            </a:pPr>
-            <a:r>
-              <a:t>Engineered for Native Android Performance</a:t>
-            </a:r>
-          </a:p>
-          <a:p>
-            <a:pPr>
-              <a:spcBef>
-                <a:spcPts val="400"/>
-              </a:spcBef>
-              <a:defRPr sz="1300">
-                <a:solidFill>
-                  <a:srgbClr val="A5AFBE"/>
-                </a:solidFill>
-                <a:latin typeface="Arial"/>
-              </a:defRPr>
-            </a:pPr>
-            <a:r>
-              <a:t>Clean MVVM architecture built with modern Kotlin and on-device machine learning.</a:t>
-            </a:r>
-          </a:p>
-        </p:txBody>
-      </p:sp>
-      <p:sp>
-        <p:nvSpPr>
-          <p:cNvPr id="5" name="Rounded Rectangle 4"/>
-          <p:cNvSpPr/>
-          <p:nvPr/>
-        </p:nvSpPr>
-        <p:spPr>
-          <a:xfrm>
-            <a:off x="731520" y="2011680"/>
-            <a:ext cx="5212080" cy="1874519"/>
-          </a:xfrm>
-          <a:prstGeom prst="roundRect">
-            <a:avLst/>
-          </a:prstGeom>
-          <a:solidFill>
-            <a:srgbClr val="181B24"/>
-          </a:solidFill>
-          <a:ln w="12700">
-            <a:solidFill>
-              <a:srgbClr val="2E3546"/>
-            </a:solidFill>
-          </a:ln>
-        </p:spPr>
-        <p:style>
-          <a:lnRef idx="1">
-            <a:schemeClr val="accent1"/>
-          </a:lnRef>
-          <a:fillRef idx="3">
-            <a:schemeClr val="accent1"/>
-          </a:fillRef>
-          <a:effectRef idx="2">
-            <a:schemeClr val="accent1"/>
-          </a:effectRef>
-          <a:fontRef idx="minor">
-            <a:schemeClr val="lt1"/>
-          </a:fontRef>
-        </p:style>
-        <p:txBody>
-          <a:bodyPr rtlCol="0" anchor="ctr" wrap="square" lIns="228600" rIns="228600" tIns="201168" bIns="201168"/>
-          <a:lstStyle/>
-          <a:p>
-            <a:pPr algn="ctr">
-              <a:spcAft>
-                <a:spcPts val="800"/>
-              </a:spcAft>
-              <a:defRPr sz="1500" b="1">
-                <a:solidFill>
-                  <a:srgbClr val="FFFFFF"/>
-                </a:solidFill>
-                <a:latin typeface="Arial"/>
-              </a:defRPr>
-            </a:pPr>
-            <a:r>
-              <a:t>🎨 UI &amp; Presentation Layer</a:t>
-            </a:r>
-          </a:p>
-          <a:p>
-            <a:pPr>
-              <a:spcAft>
-                <a:spcPts val="400"/>
-              </a:spcAft>
-              <a:defRPr sz="1200">
-                <a:solidFill>
-                  <a:srgbClr val="A5AFBE"/>
-                </a:solidFill>
-                <a:latin typeface="Arial"/>
-              </a:defRPr>
-            </a:pPr>
-            <a:r>
-              <a:t>• 100% Jetpack Compose + Material 3.</a:t>
-            </a:r>
-          </a:p>
-          <a:p>
-            <a:pPr>
-              <a:spcAft>
-                <a:spcPts val="400"/>
-              </a:spcAft>
-              <a:defRPr sz="1200">
-                <a:solidFill>
-                  <a:srgbClr val="A5AFBE"/>
-                </a:solidFill>
-                <a:latin typeface="Arial"/>
-              </a:defRPr>
-            </a:pPr>
-            <a:r>
-              <a:t>• Dark / Light / System theme switching.</a:t>
-            </a:r>
-          </a:p>
-          <a:p>
-            <a:pPr>
-              <a:spcAft>
-                <a:spcPts val="400"/>
-              </a:spcAft>
-              <a:defRPr sz="1200">
-                <a:solidFill>
-                  <a:srgbClr val="A5AFBE"/>
-                </a:solidFill>
-                <a:latin typeface="Arial"/>
-              </a:defRPr>
-            </a:pPr>
-            <a:r>
-              <a:t>• Edge-to-edge support across Android 14+.</a:t>
-            </a:r>
-          </a:p>
-          <a:p>
-            <a:pPr>
-              <a:spcAft>
-                <a:spcPts val="400"/>
-              </a:spcAft>
-              <a:defRPr sz="1200">
-                <a:solidFill>
-                  <a:srgbClr val="A5AFBE"/>
-                </a:solidFill>
-                <a:latin typeface="Arial"/>
-              </a:defRPr>
-            </a:pPr>
-            <a:r>
-              <a:t>• Integrated TrueType fonts (Calibri, Serif, Mono).</a:t>
-            </a:r>
-          </a:p>
-        </p:txBody>
-      </p:sp>
-      <p:sp>
-        <p:nvSpPr>
-          <p:cNvPr id="6" name="Rounded Rectangle 5"/>
-          <p:cNvSpPr/>
-          <p:nvPr/>
-        </p:nvSpPr>
-        <p:spPr>
-          <a:xfrm>
-            <a:off x="6217920" y="2011680"/>
-            <a:ext cx="5212080" cy="1874519"/>
-          </a:xfrm>
-          <a:prstGeom prst="roundRect">
-            <a:avLst/>
-          </a:prstGeom>
-          <a:solidFill>
-            <a:srgbClr val="181B24"/>
-          </a:solidFill>
-          <a:ln w="12700">
-            <a:solidFill>
-              <a:srgbClr val="2E3546"/>
-            </a:solidFill>
-          </a:ln>
-        </p:spPr>
-        <p:style>
-          <a:lnRef idx="1">
-            <a:schemeClr val="accent1"/>
-          </a:lnRef>
-          <a:fillRef idx="3">
-            <a:schemeClr val="accent1"/>
-          </a:fillRef>
-          <a:effectRef idx="2">
-            <a:schemeClr val="accent1"/>
-          </a:effectRef>
-          <a:fontRef idx="minor">
-            <a:schemeClr val="lt1"/>
-          </a:fontRef>
-        </p:style>
-        <p:txBody>
-          <a:bodyPr rtlCol="0" anchor="ctr" wrap="square" lIns="228600" rIns="228600" tIns="201168" bIns="201168"/>
-          <a:lstStyle/>
-          <a:p>
-            <a:pPr algn="ctr">
-              <a:spcAft>
-                <a:spcPts val="800"/>
-              </a:spcAft>
-              <a:defRPr sz="1500" b="1">
-                <a:solidFill>
-                  <a:srgbClr val="FFFFFF"/>
-                </a:solidFill>
-                <a:latin typeface="Arial"/>
-              </a:defRPr>
-            </a:pPr>
-            <a:r>
-              <a:t>🤖 On-Device AI Engine</a:t>
-            </a:r>
-          </a:p>
-          <a:p>
-            <a:pPr>
-              <a:spcAft>
-                <a:spcPts val="400"/>
-              </a:spcAft>
-              <a:defRPr sz="1200">
-                <a:solidFill>
-                  <a:srgbClr val="A5AFBE"/>
-                </a:solidFill>
-                <a:latin typeface="Arial"/>
-              </a:defRPr>
-            </a:pPr>
-            <a:r>
-              <a:t>• Google LiteRT-LM runtime engine.</a:t>
-            </a:r>
-          </a:p>
-          <a:p>
-            <a:pPr>
-              <a:spcAft>
-                <a:spcPts val="400"/>
-              </a:spcAft>
-              <a:defRPr sz="1200">
-                <a:solidFill>
-                  <a:srgbClr val="A5AFBE"/>
-                </a:solidFill>
-                <a:latin typeface="Arial"/>
-              </a:defRPr>
-            </a:pPr>
-            <a:r>
-              <a:t>• Quantized Gemma 4 E2B weights.</a:t>
-            </a:r>
-          </a:p>
-          <a:p>
-            <a:pPr>
-              <a:spcAft>
-                <a:spcPts val="400"/>
-              </a:spcAft>
-              <a:defRPr sz="1200">
-                <a:solidFill>
-                  <a:srgbClr val="A5AFBE"/>
-                </a:solidFill>
-                <a:latin typeface="Arial"/>
-              </a:defRPr>
-            </a:pPr>
-            <a:r>
-              <a:t>• OpenCL / Adreno GPU acceleration.</a:t>
-            </a:r>
-          </a:p>
-          <a:p>
-            <a:pPr>
-              <a:spcAft>
-                <a:spcPts val="400"/>
-              </a:spcAft>
-              <a:defRPr sz="1200">
-                <a:solidFill>
-                  <a:srgbClr val="A5AFBE"/>
-                </a:solidFill>
-                <a:latin typeface="Arial"/>
-              </a:defRPr>
-            </a:pPr>
-            <a:r>
-              <a:t>• Decoupled LlmEngine with test FakeEngine.</a:t>
-            </a:r>
-          </a:p>
-        </p:txBody>
-      </p:sp>
-      <p:sp>
-        <p:nvSpPr>
-          <p:cNvPr id="7" name="Rounded Rectangle 6"/>
-          <p:cNvSpPr/>
-          <p:nvPr/>
-        </p:nvSpPr>
-        <p:spPr>
-          <a:xfrm>
-            <a:off x="731520" y="4114800"/>
-            <a:ext cx="5212080" cy="1874519"/>
-          </a:xfrm>
-          <a:prstGeom prst="roundRect">
-            <a:avLst/>
-          </a:prstGeom>
-          <a:solidFill>
-            <a:srgbClr val="181B24"/>
-          </a:solidFill>
-          <a:ln w="12700">
-            <a:solidFill>
-              <a:srgbClr val="2E3546"/>
-            </a:solidFill>
-          </a:ln>
-        </p:spPr>
-        <p:style>
-          <a:lnRef idx="1">
-            <a:schemeClr val="accent1"/>
-          </a:lnRef>
-          <a:fillRef idx="3">
-            <a:schemeClr val="accent1"/>
-          </a:fillRef>
-          <a:effectRef idx="2">
-            <a:schemeClr val="accent1"/>
-          </a:effectRef>
-          <a:fontRef idx="minor">
-            <a:schemeClr val="lt1"/>
-          </a:fontRef>
-        </p:style>
-        <p:txBody>
-          <a:bodyPr rtlCol="0" anchor="ctr" wrap="square" lIns="228600" rIns="228600" tIns="201168" bIns="201168"/>
-          <a:lstStyle/>
-          <a:p>
-            <a:pPr algn="ctr">
-              <a:spcAft>
-                <a:spcPts val="800"/>
-              </a:spcAft>
-              <a:defRPr sz="1500" b="1">
-                <a:solidFill>
-                  <a:srgbClr val="FFFFFF"/>
-                </a:solidFill>
-                <a:latin typeface="Arial"/>
-              </a:defRPr>
-            </a:pPr>
-            <a:r>
-              <a:t>📥 Document Ingestion Pipeline</a:t>
-            </a:r>
-          </a:p>
-          <a:p>
-            <a:pPr>
-              <a:spcAft>
-                <a:spcPts val="400"/>
-              </a:spcAft>
-              <a:defRPr sz="1200">
-                <a:solidFill>
-                  <a:srgbClr val="A5AFBE"/>
-                </a:solidFill>
-                <a:latin typeface="Arial"/>
-              </a:defRPr>
-            </a:pPr>
-            <a:r>
-              <a:t>• Offline Google ML Kit Text Recognition v2.</a:t>
-            </a:r>
-          </a:p>
-          <a:p>
-            <a:pPr>
-              <a:spcAft>
-                <a:spcPts val="400"/>
-              </a:spcAft>
-              <a:defRPr sz="1200">
-                <a:solidFill>
-                  <a:srgbClr val="A5AFBE"/>
-                </a:solidFill>
-                <a:latin typeface="Arial"/>
-              </a:defRPr>
-            </a:pPr>
-            <a:r>
-              <a:t>• Pure local PDF extraction via pdfbox-android.</a:t>
-            </a:r>
-          </a:p>
-          <a:p>
-            <a:pPr>
-              <a:spcAft>
-                <a:spcPts val="400"/>
-              </a:spcAft>
-              <a:defRPr sz="1200">
-                <a:solidFill>
-                  <a:srgbClr val="A5AFBE"/>
-                </a:solidFill>
-                <a:latin typeface="Arial"/>
-              </a:defRPr>
-            </a:pPr>
-            <a:r>
-              <a:t>• Normalizes photos, PDF, DOCX, and text paste.</a:t>
-            </a:r>
-          </a:p>
-          <a:p>
-            <a:pPr>
-              <a:spcAft>
-                <a:spcPts val="400"/>
-              </a:spcAft>
-              <a:defRPr sz="1200">
-                <a:solidFill>
-                  <a:srgbClr val="A5AFBE"/>
-                </a:solidFill>
-                <a:latin typeface="Arial"/>
-              </a:defRPr>
-            </a:pPr>
-            <a:r>
-              <a:t>• Clean section parsing with verbatim linking.</a:t>
-            </a:r>
-          </a:p>
-        </p:txBody>
-      </p:sp>
-      <p:sp>
-        <p:nvSpPr>
-          <p:cNvPr id="8" name="Rounded Rectangle 7"/>
-          <p:cNvSpPr/>
-          <p:nvPr/>
-        </p:nvSpPr>
-        <p:spPr>
-          <a:xfrm>
-            <a:off x="6217920" y="4114800"/>
-            <a:ext cx="5212080" cy="1874519"/>
-          </a:xfrm>
-          <a:prstGeom prst="roundRect">
-            <a:avLst/>
-          </a:prstGeom>
-          <a:solidFill>
-            <a:srgbClr val="181B24"/>
-          </a:solidFill>
-          <a:ln w="12700">
-            <a:solidFill>
-              <a:srgbClr val="2E3546"/>
-            </a:solidFill>
-          </a:ln>
-        </p:spPr>
-        <p:style>
-          <a:lnRef idx="1">
-            <a:schemeClr val="accent1"/>
-          </a:lnRef>
-          <a:fillRef idx="3">
-            <a:schemeClr val="accent1"/>
-          </a:fillRef>
-          <a:effectRef idx="2">
-            <a:schemeClr val="accent1"/>
-          </a:effectRef>
-          <a:fontRef idx="minor">
-            <a:schemeClr val="lt1"/>
-          </a:fontRef>
-        </p:style>
-        <p:txBody>
-          <a:bodyPr rtlCol="0" anchor="ctr" wrap="square" lIns="228600" rIns="228600" tIns="201168" bIns="201168"/>
-          <a:lstStyle/>
-          <a:p>
-            <a:pPr algn="ctr">
-              <a:spcAft>
-                <a:spcPts val="800"/>
-              </a:spcAft>
-              <a:defRPr sz="1500" b="1">
-                <a:solidFill>
-                  <a:srgbClr val="FFFFFF"/>
-                </a:solidFill>
-                <a:latin typeface="Arial"/>
-              </a:defRPr>
-            </a:pPr>
-            <a:r>
-              <a:t>💾 Local Persistence &amp; Reliability</a:t>
-            </a:r>
-          </a:p>
-          <a:p>
-            <a:pPr>
-              <a:spcAft>
-                <a:spcPts val="400"/>
-              </a:spcAft>
-              <a:defRPr sz="1200">
-                <a:solidFill>
-                  <a:srgbClr val="A5AFBE"/>
-                </a:solidFill>
-                <a:latin typeface="Arial"/>
-              </a:defRPr>
-            </a:pPr>
-            <a:r>
-              <a:t>• Android Room Database + SharedPreferences.</a:t>
-            </a:r>
-          </a:p>
-          <a:p>
-            <a:pPr>
-              <a:spcAft>
-                <a:spcPts val="400"/>
-              </a:spcAft>
-              <a:defRPr sz="1200">
-                <a:solidFill>
-                  <a:srgbClr val="A5AFBE"/>
-                </a:solidFill>
-                <a:latin typeface="Arial"/>
-              </a:defRPr>
-            </a:pPr>
-            <a:r>
-              <a:t>• WorkManager for background model tasks.</a:t>
-            </a:r>
-          </a:p>
-          <a:p>
-            <a:pPr>
-              <a:spcAft>
-                <a:spcPts val="400"/>
-              </a:spcAft>
-              <a:defRPr sz="1200">
-                <a:solidFill>
-                  <a:srgbClr val="A5AFBE"/>
-                </a:solidFill>
-                <a:latin typeface="Arial"/>
-              </a:defRPr>
-            </a:pPr>
-            <a:r>
-              <a:t>• Model stored in persistent app storage.</a:t>
-            </a:r>
-          </a:p>
-          <a:p>
-            <a:pPr>
-              <a:spcAft>
-                <a:spcPts val="400"/>
-              </a:spcAft>
-              <a:defRPr sz="1200">
-                <a:solidFill>
-                  <a:srgbClr val="A5AFBE"/>
-                </a:solidFill>
-                <a:latin typeface="Arial"/>
-              </a:defRPr>
-            </a:pPr>
-            <a:r>
-              <a:t>• Zero network calls beyond weight download.</a:t>
-            </a:r>
-          </a:p>
-        </p:txBody>
-      </p:sp>
     </p:spTree>
   </p:cSld>
   <p:clrMapOvr>

</xml_diff>